<commit_message>
Standardize publication fonts and verification
</commit_message>
<xml_diff>
--- a/llm-rl-algorithms-2026/llm-rl-algorithms-2026.pptx
+++ b/llm-rl-algorithms-2026/llm-rl-algorithms-2026.pptx
@@ -3268,7 +3268,7 @@
                 <a:solidFill>
                   <a:srgbClr val="1B365D"/>
                 </a:solidFill>
-                <a:latin typeface="Georgia"/>
+                <a:latin typeface="TsangerJinKai02"/>
               </a:defRPr>
             </a:pPr>
             <a:r>
@@ -3304,7 +3304,7 @@
                 <a:solidFill>
                   <a:srgbClr val="141413"/>
                 </a:solidFill>
-                <a:latin typeface="Georgia"/>
+                <a:latin typeface="TsangerJinKai02"/>
               </a:defRPr>
             </a:pPr>
             <a:r>
@@ -3317,7 +3317,7 @@
                 <a:solidFill>
                   <a:srgbClr val="141413"/>
                 </a:solidFill>
-                <a:latin typeface="Georgia"/>
+                <a:latin typeface="TsangerJinKai02"/>
               </a:defRPr>
             </a:pPr>
             <a:r>
@@ -3330,7 +3330,7 @@
                 <a:solidFill>
                   <a:srgbClr val="141413"/>
                 </a:solidFill>
-                <a:latin typeface="Georgia"/>
+                <a:latin typeface="TsangerJinKai02"/>
               </a:defRPr>
             </a:pPr>
             <a:r>
@@ -3343,7 +3343,7 @@
                 <a:solidFill>
                   <a:srgbClr val="141413"/>
                 </a:solidFill>
-                <a:latin typeface="Georgia"/>
+                <a:latin typeface="TsangerJinKai02"/>
               </a:defRPr>
             </a:pPr>
             <a:r>
@@ -3520,7 +3520,7 @@
                 <a:solidFill>
                   <a:srgbClr val="1B365D"/>
                 </a:solidFill>
-                <a:latin typeface="Georgia"/>
+                <a:latin typeface="TsangerJinKai02"/>
               </a:defRPr>
             </a:pPr>
             <a:r>
@@ -3546,7 +3546,7 @@
         <p:spPr>
           <a:xfrm>
             <a:off x="685800" y="1298448"/>
-            <a:ext cx="8778240" cy="952677"/>
+            <a:ext cx="8778240" cy="940157"/>
           </a:xfrm>
           <a:prstGeom prst="rect">
             <a:avLst/>
@@ -3580,7 +3580,7 @@
                 <a:solidFill>
                   <a:srgbClr val="141413"/>
                 </a:solidFill>
-                <a:latin typeface="Georgia"/>
+                <a:latin typeface="TsangerJinKai02"/>
               </a:defRPr>
             </a:pPr>
             <a:r>
@@ -3593,7 +3593,7 @@
                 <a:solidFill>
                   <a:srgbClr val="141413"/>
                 </a:solidFill>
-                <a:latin typeface="Georgia"/>
+                <a:latin typeface="TsangerJinKai02"/>
               </a:defRPr>
             </a:pPr>
             <a:r>
@@ -3606,7 +3606,7 @@
                 <a:solidFill>
                   <a:srgbClr val="141413"/>
                 </a:solidFill>
-                <a:latin typeface="Georgia"/>
+                <a:latin typeface="TsangerJinKai02"/>
               </a:defRPr>
             </a:pPr>
             <a:r>
@@ -3619,7 +3619,7 @@
                 <a:solidFill>
                   <a:srgbClr val="141413"/>
                 </a:solidFill>
-                <a:latin typeface="Georgia"/>
+                <a:latin typeface="TsangerJinKai02"/>
               </a:defRPr>
             </a:pPr>
             <a:r>
@@ -3796,7 +3796,7 @@
                 <a:solidFill>
                   <a:srgbClr val="1B365D"/>
                 </a:solidFill>
-                <a:latin typeface="Georgia"/>
+                <a:latin typeface="TsangerJinKai02"/>
               </a:defRPr>
             </a:pPr>
             <a:r>
@@ -3822,7 +3822,7 @@
         <p:spPr>
           <a:xfrm>
             <a:off x="685800" y="1298448"/>
-            <a:ext cx="8778240" cy="510734"/>
+            <a:ext cx="8778240" cy="514953"/>
           </a:xfrm>
           <a:prstGeom prst="rect">
             <a:avLst/>
@@ -3856,7 +3856,7 @@
                 <a:solidFill>
                   <a:srgbClr val="141413"/>
                 </a:solidFill>
-                <a:latin typeface="Georgia"/>
+                <a:latin typeface="TsangerJinKai02"/>
               </a:defRPr>
             </a:pPr>
             <a:r>
@@ -3869,7 +3869,7 @@
                 <a:solidFill>
                   <a:srgbClr val="141413"/>
                 </a:solidFill>
-                <a:latin typeface="Georgia"/>
+                <a:latin typeface="TsangerJinKai02"/>
               </a:defRPr>
             </a:pPr>
             <a:r>
@@ -3882,7 +3882,7 @@
                 <a:solidFill>
                   <a:srgbClr val="141413"/>
                 </a:solidFill>
-                <a:latin typeface="Georgia"/>
+                <a:latin typeface="TsangerJinKai02"/>
               </a:defRPr>
             </a:pPr>
             <a:r>
@@ -3895,7 +3895,7 @@
                 <a:solidFill>
                   <a:srgbClr val="141413"/>
                 </a:solidFill>
-                <a:latin typeface="Georgia"/>
+                <a:latin typeface="TsangerJinKai02"/>
               </a:defRPr>
             </a:pPr>
             <a:r>
@@ -3908,7 +3908,7 @@
                 <a:solidFill>
                   <a:srgbClr val="141413"/>
                 </a:solidFill>
-                <a:latin typeface="Georgia"/>
+                <a:latin typeface="TsangerJinKai02"/>
               </a:defRPr>
             </a:pPr>
             <a:r>
@@ -4085,7 +4085,7 @@
                 <a:solidFill>
                   <a:srgbClr val="1B365D"/>
                 </a:solidFill>
-                <a:latin typeface="Georgia"/>
+                <a:latin typeface="TsangerJinKai02"/>
               </a:defRPr>
             </a:pPr>
             <a:r>
@@ -4111,7 +4111,7 @@
         <p:spPr>
           <a:xfrm>
             <a:off x="685800" y="1298448"/>
-            <a:ext cx="8778240" cy="1219200"/>
+            <a:ext cx="8778240" cy="1219196"/>
           </a:xfrm>
           <a:prstGeom prst="rect">
             <a:avLst/>
@@ -4145,7 +4145,7 @@
                 <a:solidFill>
                   <a:srgbClr val="141413"/>
                 </a:solidFill>
-                <a:latin typeface="Georgia"/>
+                <a:latin typeface="TsangerJinKai02"/>
               </a:defRPr>
             </a:pPr>
             <a:r>
@@ -4158,7 +4158,7 @@
                 <a:solidFill>
                   <a:srgbClr val="141413"/>
                 </a:solidFill>
-                <a:latin typeface="Georgia"/>
+                <a:latin typeface="TsangerJinKai02"/>
               </a:defRPr>
             </a:pPr>
             <a:r>
@@ -4171,7 +4171,7 @@
                 <a:solidFill>
                   <a:srgbClr val="141413"/>
                 </a:solidFill>
-                <a:latin typeface="Georgia"/>
+                <a:latin typeface="TsangerJinKai02"/>
               </a:defRPr>
             </a:pPr>
             <a:r>
@@ -4184,7 +4184,7 @@
                 <a:solidFill>
                   <a:srgbClr val="141413"/>
                 </a:solidFill>
-                <a:latin typeface="Georgia"/>
+                <a:latin typeface="TsangerJinKai02"/>
               </a:defRPr>
             </a:pPr>
             <a:r>
@@ -4361,7 +4361,7 @@
                 <a:solidFill>
                   <a:srgbClr val="1B365D"/>
                 </a:solidFill>
-                <a:latin typeface="Georgia"/>
+                <a:latin typeface="TsangerJinKai02"/>
               </a:defRPr>
             </a:pPr>
             <a:r>
@@ -4387,7 +4387,7 @@
         <p:spPr>
           <a:xfrm>
             <a:off x="685800" y="1298448"/>
-            <a:ext cx="8778240" cy="1350498"/>
+            <a:ext cx="8778240" cy="1340957"/>
           </a:xfrm>
           <a:prstGeom prst="rect">
             <a:avLst/>
@@ -4421,7 +4421,7 @@
                 <a:solidFill>
                   <a:srgbClr val="141413"/>
                 </a:solidFill>
-                <a:latin typeface="Georgia"/>
+                <a:latin typeface="TsangerJinKai02"/>
               </a:defRPr>
             </a:pPr>
             <a:r>
@@ -4434,7 +4434,7 @@
                 <a:solidFill>
                   <a:srgbClr val="141413"/>
                 </a:solidFill>
-                <a:latin typeface="Georgia"/>
+                <a:latin typeface="TsangerJinKai02"/>
               </a:defRPr>
             </a:pPr>
             <a:r>
@@ -4447,7 +4447,7 @@
                 <a:solidFill>
                   <a:srgbClr val="141413"/>
                 </a:solidFill>
-                <a:latin typeface="Georgia"/>
+                <a:latin typeface="TsangerJinKai02"/>
               </a:defRPr>
             </a:pPr>
             <a:r>
@@ -4460,7 +4460,7 @@
                 <a:solidFill>
                   <a:srgbClr val="141413"/>
                 </a:solidFill>
-                <a:latin typeface="Georgia"/>
+                <a:latin typeface="TsangerJinKai02"/>
               </a:defRPr>
             </a:pPr>
             <a:r>
@@ -4637,7 +4637,7 @@
                 <a:solidFill>
                   <a:srgbClr val="1B365D"/>
                 </a:solidFill>
-                <a:latin typeface="Georgia"/>
+                <a:latin typeface="TsangerJinKai02"/>
               </a:defRPr>
             </a:pPr>
             <a:r>
@@ -4663,7 +4663,7 @@
         <p:spPr>
           <a:xfrm>
             <a:off x="685800" y="1298448"/>
-            <a:ext cx="8778240" cy="386140"/>
+            <a:ext cx="8778240" cy="395065"/>
           </a:xfrm>
           <a:prstGeom prst="rect">
             <a:avLst/>
@@ -4697,7 +4697,7 @@
                 <a:solidFill>
                   <a:srgbClr val="141413"/>
                 </a:solidFill>
-                <a:latin typeface="Georgia"/>
+                <a:latin typeface="TsangerJinKai02"/>
               </a:defRPr>
             </a:pPr>
             <a:r>
@@ -4710,7 +4710,7 @@
                 <a:solidFill>
                   <a:srgbClr val="141413"/>
                 </a:solidFill>
-                <a:latin typeface="Georgia"/>
+                <a:latin typeface="TsangerJinKai02"/>
               </a:defRPr>
             </a:pPr>
             <a:r>
@@ -4723,7 +4723,7 @@
                 <a:solidFill>
                   <a:srgbClr val="141413"/>
                 </a:solidFill>
-                <a:latin typeface="Georgia"/>
+                <a:latin typeface="TsangerJinKai02"/>
               </a:defRPr>
             </a:pPr>
             <a:r>
@@ -4736,7 +4736,7 @@
                 <a:solidFill>
                   <a:srgbClr val="141413"/>
                 </a:solidFill>
-                <a:latin typeface="Georgia"/>
+                <a:latin typeface="TsangerJinKai02"/>
               </a:defRPr>
             </a:pPr>
             <a:r>
@@ -4913,7 +4913,7 @@
                 <a:solidFill>
                   <a:srgbClr val="1B365D"/>
                 </a:solidFill>
-                <a:latin typeface="Georgia"/>
+                <a:latin typeface="TsangerJinKai02"/>
               </a:defRPr>
             </a:pPr>
             <a:r>
@@ -4939,7 +4939,7 @@
         <p:spPr>
           <a:xfrm>
             <a:off x="685800" y="1298448"/>
-            <a:ext cx="8778240" cy="1582961"/>
+            <a:ext cx="8778240" cy="1570837"/>
           </a:xfrm>
           <a:prstGeom prst="rect">
             <a:avLst/>
@@ -4973,7 +4973,7 @@
                 <a:solidFill>
                   <a:srgbClr val="141413"/>
                 </a:solidFill>
-                <a:latin typeface="Georgia"/>
+                <a:latin typeface="TsangerJinKai02"/>
               </a:defRPr>
             </a:pPr>
             <a:r>
@@ -4986,7 +4986,7 @@
                 <a:solidFill>
                   <a:srgbClr val="141413"/>
                 </a:solidFill>
-                <a:latin typeface="Georgia"/>
+                <a:latin typeface="TsangerJinKai02"/>
               </a:defRPr>
             </a:pPr>
             <a:r>
@@ -4999,7 +4999,7 @@
                 <a:solidFill>
                   <a:srgbClr val="141413"/>
                 </a:solidFill>
-                <a:latin typeface="Georgia"/>
+                <a:latin typeface="TsangerJinKai02"/>
               </a:defRPr>
             </a:pPr>
             <a:r>
@@ -5012,7 +5012,7 @@
                 <a:solidFill>
                   <a:srgbClr val="141413"/>
                 </a:solidFill>
-                <a:latin typeface="Georgia"/>
+                <a:latin typeface="TsangerJinKai02"/>
               </a:defRPr>
             </a:pPr>
             <a:r>
@@ -5189,7 +5189,7 @@
                 <a:solidFill>
                   <a:srgbClr val="1B365D"/>
                 </a:solidFill>
-                <a:latin typeface="Georgia"/>
+                <a:latin typeface="TsangerJinKai02"/>
               </a:defRPr>
             </a:pPr>
             <a:r>
@@ -5215,7 +5215,7 @@
         <p:spPr>
           <a:xfrm>
             <a:off x="685800" y="1298448"/>
-            <a:ext cx="8778240" cy="538542"/>
+            <a:ext cx="8778240" cy="554303"/>
           </a:xfrm>
           <a:prstGeom prst="rect">
             <a:avLst/>
@@ -5249,7 +5249,7 @@
                 <a:solidFill>
                   <a:srgbClr val="141413"/>
                 </a:solidFill>
-                <a:latin typeface="Georgia"/>
+                <a:latin typeface="TsangerJinKai02"/>
               </a:defRPr>
             </a:pPr>
             <a:r>
@@ -5262,7 +5262,7 @@
                 <a:solidFill>
                   <a:srgbClr val="141413"/>
                 </a:solidFill>
-                <a:latin typeface="Georgia"/>
+                <a:latin typeface="TsangerJinKai02"/>
               </a:defRPr>
             </a:pPr>
             <a:r>
@@ -5275,7 +5275,7 @@
                 <a:solidFill>
                   <a:srgbClr val="141413"/>
                 </a:solidFill>
-                <a:latin typeface="Georgia"/>
+                <a:latin typeface="TsangerJinKai02"/>
               </a:defRPr>
             </a:pPr>
             <a:r>
@@ -5288,7 +5288,7 @@
                 <a:solidFill>
                   <a:srgbClr val="141413"/>
                 </a:solidFill>
-                <a:latin typeface="Georgia"/>
+                <a:latin typeface="TsangerJinKai02"/>
               </a:defRPr>
             </a:pPr>
             <a:r>
@@ -5465,7 +5465,7 @@
                 <a:solidFill>
                   <a:srgbClr val="1B365D"/>
                 </a:solidFill>
-                <a:latin typeface="Georgia"/>
+                <a:latin typeface="TsangerJinKai02"/>
               </a:defRPr>
             </a:pPr>
             <a:r>
@@ -5491,7 +5491,7 @@
         <p:spPr>
           <a:xfrm>
             <a:off x="685800" y="1298448"/>
-            <a:ext cx="8778240" cy="1300480"/>
+            <a:ext cx="8778240" cy="1270319"/>
           </a:xfrm>
           <a:prstGeom prst="rect">
             <a:avLst/>
@@ -5525,7 +5525,7 @@
                 <a:solidFill>
                   <a:srgbClr val="141413"/>
                 </a:solidFill>
-                <a:latin typeface="Georgia"/>
+                <a:latin typeface="TsangerJinKai02"/>
               </a:defRPr>
             </a:pPr>
             <a:r>
@@ -5538,7 +5538,7 @@
                 <a:solidFill>
                   <a:srgbClr val="141413"/>
                 </a:solidFill>
-                <a:latin typeface="Georgia"/>
+                <a:latin typeface="TsangerJinKai02"/>
               </a:defRPr>
             </a:pPr>
             <a:r>
@@ -5551,7 +5551,7 @@
                 <a:solidFill>
                   <a:srgbClr val="141413"/>
                 </a:solidFill>
-                <a:latin typeface="Georgia"/>
+                <a:latin typeface="TsangerJinKai02"/>
               </a:defRPr>
             </a:pPr>
             <a:r>
@@ -5564,7 +5564,7 @@
                 <a:solidFill>
                   <a:srgbClr val="141413"/>
                 </a:solidFill>
-                <a:latin typeface="Georgia"/>
+                <a:latin typeface="TsangerJinKai02"/>
               </a:defRPr>
             </a:pPr>
             <a:r>
@@ -5741,7 +5741,7 @@
                 <a:solidFill>
                   <a:srgbClr val="1B365D"/>
                 </a:solidFill>
-                <a:latin typeface="Georgia"/>
+                <a:latin typeface="TsangerJinKai02"/>
               </a:defRPr>
             </a:pPr>
             <a:r>
@@ -5767,7 +5767,7 @@
         <p:spPr>
           <a:xfrm>
             <a:off x="685800" y="1298448"/>
-            <a:ext cx="8778240" cy="908094"/>
+            <a:ext cx="8778240" cy="907310"/>
           </a:xfrm>
           <a:prstGeom prst="rect">
             <a:avLst/>
@@ -5801,7 +5801,7 @@
                 <a:solidFill>
                   <a:srgbClr val="141413"/>
                 </a:solidFill>
-                <a:latin typeface="Georgia"/>
+                <a:latin typeface="TsangerJinKai02"/>
               </a:defRPr>
             </a:pPr>
             <a:r>
@@ -5814,7 +5814,7 @@
                 <a:solidFill>
                   <a:srgbClr val="141413"/>
                 </a:solidFill>
-                <a:latin typeface="Georgia"/>
+                <a:latin typeface="TsangerJinKai02"/>
               </a:defRPr>
             </a:pPr>
             <a:r>
@@ -5827,7 +5827,7 @@
                 <a:solidFill>
                   <a:srgbClr val="141413"/>
                 </a:solidFill>
-                <a:latin typeface="Georgia"/>
+                <a:latin typeface="TsangerJinKai02"/>
               </a:defRPr>
             </a:pPr>
             <a:r>
@@ -5840,7 +5840,7 @@
                 <a:solidFill>
                   <a:srgbClr val="141413"/>
                 </a:solidFill>
-                <a:latin typeface="Georgia"/>
+                <a:latin typeface="TsangerJinKai02"/>
               </a:defRPr>
             </a:pPr>
             <a:r>
@@ -6017,7 +6017,7 @@
                 <a:solidFill>
                   <a:srgbClr val="1B365D"/>
                 </a:solidFill>
-                <a:latin typeface="Georgia"/>
+                <a:latin typeface="TsangerJinKai02"/>
               </a:defRPr>
             </a:pPr>
             <a:r>
@@ -6053,7 +6053,7 @@
                 <a:solidFill>
                   <a:srgbClr val="141413"/>
                 </a:solidFill>
-                <a:latin typeface="Georgia"/>
+                <a:latin typeface="TsangerJinKai02"/>
               </a:defRPr>
             </a:pPr>
             <a:r>
@@ -6066,7 +6066,7 @@
                 <a:solidFill>
                   <a:srgbClr val="141413"/>
                 </a:solidFill>
-                <a:latin typeface="Georgia"/>
+                <a:latin typeface="TsangerJinKai02"/>
               </a:defRPr>
             </a:pPr>
             <a:r>
@@ -6079,7 +6079,7 @@
                 <a:solidFill>
                   <a:srgbClr val="141413"/>
                 </a:solidFill>
-                <a:latin typeface="Georgia"/>
+                <a:latin typeface="TsangerJinKai02"/>
               </a:defRPr>
             </a:pPr>
             <a:r>
@@ -6092,7 +6092,7 @@
                 <a:solidFill>
                   <a:srgbClr val="141413"/>
                 </a:solidFill>
-                <a:latin typeface="Georgia"/>
+                <a:latin typeface="TsangerJinKai02"/>
               </a:defRPr>
             </a:pPr>
             <a:r>
@@ -6105,7 +6105,7 @@
                 <a:solidFill>
                   <a:srgbClr val="141413"/>
                 </a:solidFill>
-                <a:latin typeface="Georgia"/>
+                <a:latin typeface="TsangerJinKai02"/>
               </a:defRPr>
             </a:pPr>
             <a:r>
@@ -6282,7 +6282,7 @@
                 <a:solidFill>
                   <a:srgbClr val="1B365D"/>
                 </a:solidFill>
-                <a:latin typeface="Georgia"/>
+                <a:latin typeface="TsangerJinKai02"/>
               </a:defRPr>
             </a:pPr>
             <a:r>
@@ -6318,7 +6318,7 @@
                 <a:solidFill>
                   <a:srgbClr val="141413"/>
                 </a:solidFill>
-                <a:latin typeface="Georgia"/>
+                <a:latin typeface="TsangerJinKai02"/>
               </a:defRPr>
             </a:pPr>
             <a:r>
@@ -6331,7 +6331,7 @@
                 <a:solidFill>
                   <a:srgbClr val="141413"/>
                 </a:solidFill>
-                <a:latin typeface="Georgia"/>
+                <a:latin typeface="TsangerJinKai02"/>
               </a:defRPr>
             </a:pPr>
             <a:r>
@@ -6344,7 +6344,7 @@
                 <a:solidFill>
                   <a:srgbClr val="141413"/>
                 </a:solidFill>
-                <a:latin typeface="Georgia"/>
+                <a:latin typeface="TsangerJinKai02"/>
               </a:defRPr>
             </a:pPr>
             <a:r>
@@ -6357,7 +6357,7 @@
                 <a:solidFill>
                   <a:srgbClr val="141413"/>
                 </a:solidFill>
-                <a:latin typeface="Georgia"/>
+                <a:latin typeface="TsangerJinKai02"/>
               </a:defRPr>
             </a:pPr>
             <a:r>
@@ -6534,7 +6534,7 @@
                 <a:solidFill>
                   <a:srgbClr val="1B365D"/>
                 </a:solidFill>
-                <a:latin typeface="Georgia"/>
+                <a:latin typeface="TsangerJinKai02"/>
               </a:defRPr>
             </a:pPr>
             <a:r>
@@ -6560,7 +6560,7 @@
         <p:spPr>
           <a:xfrm>
             <a:off x="685800" y="1298448"/>
-            <a:ext cx="8778240" cy="315764"/>
+            <a:ext cx="8778240" cy="312491"/>
           </a:xfrm>
           <a:prstGeom prst="rect">
             <a:avLst/>
@@ -6594,7 +6594,7 @@
                 <a:solidFill>
                   <a:srgbClr val="141413"/>
                 </a:solidFill>
-                <a:latin typeface="Georgia"/>
+                <a:latin typeface="TsangerJinKai02"/>
               </a:defRPr>
             </a:pPr>
             <a:r>
@@ -6607,7 +6607,7 @@
                 <a:solidFill>
                   <a:srgbClr val="141413"/>
                 </a:solidFill>
-                <a:latin typeface="Georgia"/>
+                <a:latin typeface="TsangerJinKai02"/>
               </a:defRPr>
             </a:pPr>
             <a:r>
@@ -6620,7 +6620,7 @@
                 <a:solidFill>
                   <a:srgbClr val="141413"/>
                 </a:solidFill>
-                <a:latin typeface="Georgia"/>
+                <a:latin typeface="TsangerJinKai02"/>
               </a:defRPr>
             </a:pPr>
             <a:r>
@@ -6633,7 +6633,7 @@
                 <a:solidFill>
                   <a:srgbClr val="141413"/>
                 </a:solidFill>
-                <a:latin typeface="Georgia"/>
+                <a:latin typeface="TsangerJinKai02"/>
               </a:defRPr>
             </a:pPr>
             <a:r>
@@ -6810,7 +6810,7 @@
                 <a:solidFill>
                   <a:srgbClr val="1B365D"/>
                 </a:solidFill>
-                <a:latin typeface="Georgia"/>
+                <a:latin typeface="TsangerJinKai02"/>
               </a:defRPr>
             </a:pPr>
             <a:r>
@@ -6836,7 +6836,7 @@
         <p:spPr>
           <a:xfrm>
             <a:off x="685800" y="1298448"/>
-            <a:ext cx="8778240" cy="1351885"/>
+            <a:ext cx="8778240" cy="1366100"/>
           </a:xfrm>
           <a:prstGeom prst="rect">
             <a:avLst/>
@@ -6870,7 +6870,7 @@
                 <a:solidFill>
                   <a:srgbClr val="141413"/>
                 </a:solidFill>
-                <a:latin typeface="Georgia"/>
+                <a:latin typeface="TsangerJinKai02"/>
               </a:defRPr>
             </a:pPr>
             <a:r>
@@ -6883,7 +6883,7 @@
                 <a:solidFill>
                   <a:srgbClr val="141413"/>
                 </a:solidFill>
-                <a:latin typeface="Georgia"/>
+                <a:latin typeface="TsangerJinKai02"/>
               </a:defRPr>
             </a:pPr>
             <a:r>
@@ -6896,7 +6896,7 @@
                 <a:solidFill>
                   <a:srgbClr val="141413"/>
                 </a:solidFill>
-                <a:latin typeface="Georgia"/>
+                <a:latin typeface="TsangerJinKai02"/>
               </a:defRPr>
             </a:pPr>
             <a:r>
@@ -6909,7 +6909,7 @@
                 <a:solidFill>
                   <a:srgbClr val="141413"/>
                 </a:solidFill>
-                <a:latin typeface="Georgia"/>
+                <a:latin typeface="TsangerJinKai02"/>
               </a:defRPr>
             </a:pPr>
             <a:r>
@@ -7086,7 +7086,7 @@
                 <a:solidFill>
                   <a:srgbClr val="1B365D"/>
                 </a:solidFill>
-                <a:latin typeface="Georgia"/>
+                <a:latin typeface="TsangerJinKai02"/>
               </a:defRPr>
             </a:pPr>
             <a:r>
@@ -7112,7 +7112,7 @@
         <p:spPr>
           <a:xfrm>
             <a:off x="685800" y="1298448"/>
-            <a:ext cx="8778240" cy="1165253"/>
+            <a:ext cx="8778240" cy="1164218"/>
           </a:xfrm>
           <a:prstGeom prst="rect">
             <a:avLst/>
@@ -7146,7 +7146,7 @@
                 <a:solidFill>
                   <a:srgbClr val="141413"/>
                 </a:solidFill>
-                <a:latin typeface="Georgia"/>
+                <a:latin typeface="TsangerJinKai02"/>
               </a:defRPr>
             </a:pPr>
             <a:r>
@@ -7159,7 +7159,7 @@
                 <a:solidFill>
                   <a:srgbClr val="141413"/>
                 </a:solidFill>
-                <a:latin typeface="Georgia"/>
+                <a:latin typeface="TsangerJinKai02"/>
               </a:defRPr>
             </a:pPr>
             <a:r>
@@ -7172,7 +7172,7 @@
                 <a:solidFill>
                   <a:srgbClr val="141413"/>
                 </a:solidFill>
-                <a:latin typeface="Georgia"/>
+                <a:latin typeface="TsangerJinKai02"/>
               </a:defRPr>
             </a:pPr>
             <a:r>
@@ -7185,7 +7185,7 @@
                 <a:solidFill>
                   <a:srgbClr val="141413"/>
                 </a:solidFill>
-                <a:latin typeface="Georgia"/>
+                <a:latin typeface="TsangerJinKai02"/>
               </a:defRPr>
             </a:pPr>
             <a:r>
@@ -7362,7 +7362,7 @@
                 <a:solidFill>
                   <a:srgbClr val="1B365D"/>
                 </a:solidFill>
-                <a:latin typeface="Georgia"/>
+                <a:latin typeface="TsangerJinKai02"/>
               </a:defRPr>
             </a:pPr>
             <a:r>
@@ -7388,7 +7388,7 @@
         <p:spPr>
           <a:xfrm>
             <a:off x="685800" y="1298448"/>
-            <a:ext cx="8778240" cy="2698074"/>
+            <a:ext cx="8778240" cy="2717412"/>
           </a:xfrm>
           <a:prstGeom prst="rect">
             <a:avLst/>
@@ -7422,7 +7422,7 @@
                 <a:solidFill>
                   <a:srgbClr val="141413"/>
                 </a:solidFill>
-                <a:latin typeface="Georgia"/>
+                <a:latin typeface="TsangerJinKai02"/>
               </a:defRPr>
             </a:pPr>
             <a:r>
@@ -7435,7 +7435,7 @@
                 <a:solidFill>
                   <a:srgbClr val="141413"/>
                 </a:solidFill>
-                <a:latin typeface="Georgia"/>
+                <a:latin typeface="TsangerJinKai02"/>
               </a:defRPr>
             </a:pPr>
             <a:r>
@@ -7448,7 +7448,7 @@
                 <a:solidFill>
                   <a:srgbClr val="141413"/>
                 </a:solidFill>
-                <a:latin typeface="Georgia"/>
+                <a:latin typeface="TsangerJinKai02"/>
               </a:defRPr>
             </a:pPr>
             <a:r>
@@ -7461,7 +7461,7 @@
                 <a:solidFill>
                   <a:srgbClr val="141413"/>
                 </a:solidFill>
-                <a:latin typeface="Georgia"/>
+                <a:latin typeface="TsangerJinKai02"/>
               </a:defRPr>
             </a:pPr>
             <a:r>
@@ -7638,7 +7638,7 @@
                 <a:solidFill>
                   <a:srgbClr val="1B365D"/>
                 </a:solidFill>
-                <a:latin typeface="Georgia"/>
+                <a:latin typeface="TsangerJinKai02"/>
               </a:defRPr>
             </a:pPr>
             <a:r>
@@ -7664,7 +7664,7 @@
         <p:spPr>
           <a:xfrm>
             <a:off x="685800" y="1298448"/>
-            <a:ext cx="8778240" cy="648638"/>
+            <a:ext cx="8778240" cy="648437"/>
           </a:xfrm>
           <a:prstGeom prst="rect">
             <a:avLst/>
@@ -7698,7 +7698,7 @@
                 <a:solidFill>
                   <a:srgbClr val="141413"/>
                 </a:solidFill>
-                <a:latin typeface="Georgia"/>
+                <a:latin typeface="TsangerJinKai02"/>
               </a:defRPr>
             </a:pPr>
             <a:r>
@@ -7711,7 +7711,7 @@
                 <a:solidFill>
                   <a:srgbClr val="141413"/>
                 </a:solidFill>
-                <a:latin typeface="Georgia"/>
+                <a:latin typeface="TsangerJinKai02"/>
               </a:defRPr>
             </a:pPr>
             <a:r>
@@ -7724,7 +7724,7 @@
                 <a:solidFill>
                   <a:srgbClr val="141413"/>
                 </a:solidFill>
-                <a:latin typeface="Georgia"/>
+                <a:latin typeface="TsangerJinKai02"/>
               </a:defRPr>
             </a:pPr>
             <a:r>
@@ -7737,7 +7737,7 @@
                 <a:solidFill>
                   <a:srgbClr val="141413"/>
                 </a:solidFill>
-                <a:latin typeface="Georgia"/>
+                <a:latin typeface="TsangerJinKai02"/>
               </a:defRPr>
             </a:pPr>
             <a:r>
@@ -7914,7 +7914,7 @@
                 <a:solidFill>
                   <a:srgbClr val="1B365D"/>
                 </a:solidFill>
-                <a:latin typeface="Georgia"/>
+                <a:latin typeface="TsangerJinKai02"/>
               </a:defRPr>
             </a:pPr>
             <a:r>
@@ -7940,7 +7940,7 @@
         <p:spPr>
           <a:xfrm>
             <a:off x="685800" y="1298448"/>
-            <a:ext cx="8778240" cy="798022"/>
+            <a:ext cx="8778240" cy="798020"/>
           </a:xfrm>
           <a:prstGeom prst="rect">
             <a:avLst/>
@@ -7974,7 +7974,7 @@
                 <a:solidFill>
                   <a:srgbClr val="141413"/>
                 </a:solidFill>
-                <a:latin typeface="Georgia"/>
+                <a:latin typeface="TsangerJinKai02"/>
               </a:defRPr>
             </a:pPr>
             <a:r>
@@ -7987,7 +7987,7 @@
                 <a:solidFill>
                   <a:srgbClr val="141413"/>
                 </a:solidFill>
-                <a:latin typeface="Georgia"/>
+                <a:latin typeface="TsangerJinKai02"/>
               </a:defRPr>
             </a:pPr>
             <a:r>
@@ -8000,7 +8000,7 @@
                 <a:solidFill>
                   <a:srgbClr val="141413"/>
                 </a:solidFill>
-                <a:latin typeface="Georgia"/>
+                <a:latin typeface="TsangerJinKai02"/>
               </a:defRPr>
             </a:pPr>
             <a:r>
@@ -8013,7 +8013,7 @@
                 <a:solidFill>
                   <a:srgbClr val="141413"/>
                 </a:solidFill>
-                <a:latin typeface="Georgia"/>
+                <a:latin typeface="TsangerJinKai02"/>
               </a:defRPr>
             </a:pPr>
             <a:r>
@@ -8190,7 +8190,7 @@
                 <a:solidFill>
                   <a:srgbClr val="1B365D"/>
                 </a:solidFill>
-                <a:latin typeface="Georgia"/>
+                <a:latin typeface="TsangerJinKai02"/>
               </a:defRPr>
             </a:pPr>
             <a:r>
@@ -8226,7 +8226,7 @@
                 <a:solidFill>
                   <a:srgbClr val="141413"/>
                 </a:solidFill>
-                <a:latin typeface="Georgia"/>
+                <a:latin typeface="TsangerJinKai02"/>
               </a:defRPr>
             </a:pPr>
             <a:r>
@@ -8239,7 +8239,7 @@
                 <a:solidFill>
                   <a:srgbClr val="141413"/>
                 </a:solidFill>
-                <a:latin typeface="Georgia"/>
+                <a:latin typeface="TsangerJinKai02"/>
               </a:defRPr>
             </a:pPr>
             <a:r>
@@ -8252,7 +8252,7 @@
                 <a:solidFill>
                   <a:srgbClr val="141413"/>
                 </a:solidFill>
-                <a:latin typeface="Georgia"/>
+                <a:latin typeface="TsangerJinKai02"/>
               </a:defRPr>
             </a:pPr>
             <a:r>
@@ -8265,7 +8265,7 @@
                 <a:solidFill>
                   <a:srgbClr val="141413"/>
                 </a:solidFill>
-                <a:latin typeface="Georgia"/>
+                <a:latin typeface="TsangerJinKai02"/>
               </a:defRPr>
             </a:pPr>
             <a:r>
@@ -8442,7 +8442,7 @@
                 <a:solidFill>
                   <a:srgbClr val="1B365D"/>
                 </a:solidFill>
-                <a:latin typeface="Georgia"/>
+                <a:latin typeface="TsangerJinKai02"/>
               </a:defRPr>
             </a:pPr>
             <a:r>
@@ -8478,7 +8478,7 @@
                 <a:solidFill>
                   <a:srgbClr val="141413"/>
                 </a:solidFill>
-                <a:latin typeface="Georgia"/>
+                <a:latin typeface="TsangerJinKai02"/>
               </a:defRPr>
             </a:pPr>
             <a:r>
@@ -8491,7 +8491,7 @@
                 <a:solidFill>
                   <a:srgbClr val="141413"/>
                 </a:solidFill>
-                <a:latin typeface="Georgia"/>
+                <a:latin typeface="TsangerJinKai02"/>
               </a:defRPr>
             </a:pPr>
             <a:r>
@@ -8504,7 +8504,7 @@
                 <a:solidFill>
                   <a:srgbClr val="141413"/>
                 </a:solidFill>
-                <a:latin typeface="Georgia"/>
+                <a:latin typeface="TsangerJinKai02"/>
               </a:defRPr>
             </a:pPr>
             <a:r>
@@ -8517,7 +8517,7 @@
                 <a:solidFill>
                   <a:srgbClr val="141413"/>
                 </a:solidFill>
-                <a:latin typeface="Georgia"/>
+                <a:latin typeface="TsangerJinKai02"/>
               </a:defRPr>
             </a:pPr>
             <a:r>
@@ -8530,7 +8530,7 @@
                 <a:solidFill>
                   <a:srgbClr val="141413"/>
                 </a:solidFill>
-                <a:latin typeface="Georgia"/>
+                <a:latin typeface="TsangerJinKai02"/>
               </a:defRPr>
             </a:pPr>
             <a:r>
@@ -8707,7 +8707,7 @@
                 <a:solidFill>
                   <a:srgbClr val="1B365D"/>
                 </a:solidFill>
-                <a:latin typeface="Georgia"/>
+                <a:latin typeface="TsangerJinKai02"/>
               </a:defRPr>
             </a:pPr>
             <a:r>
@@ -8743,7 +8743,7 @@
                 <a:solidFill>
                   <a:srgbClr val="141413"/>
                 </a:solidFill>
-                <a:latin typeface="Georgia"/>
+                <a:latin typeface="TsangerJinKai02"/>
               </a:defRPr>
             </a:pPr>
             <a:r>
@@ -8756,7 +8756,7 @@
                 <a:solidFill>
                   <a:srgbClr val="141413"/>
                 </a:solidFill>
-                <a:latin typeface="Georgia"/>
+                <a:latin typeface="TsangerJinKai02"/>
               </a:defRPr>
             </a:pPr>
             <a:r>
@@ -8769,7 +8769,7 @@
                 <a:solidFill>
                   <a:srgbClr val="141413"/>
                 </a:solidFill>
-                <a:latin typeface="Georgia"/>
+                <a:latin typeface="TsangerJinKai02"/>
               </a:defRPr>
             </a:pPr>
             <a:r>
@@ -8782,7 +8782,7 @@
                 <a:solidFill>
                   <a:srgbClr val="141413"/>
                 </a:solidFill>
-                <a:latin typeface="Georgia"/>
+                <a:latin typeface="TsangerJinKai02"/>
               </a:defRPr>
             </a:pPr>
             <a:r>
@@ -8795,7 +8795,7 @@
                 <a:solidFill>
                   <a:srgbClr val="141413"/>
                 </a:solidFill>
-                <a:latin typeface="Georgia"/>
+                <a:latin typeface="TsangerJinKai02"/>
               </a:defRPr>
             </a:pPr>
             <a:r>
@@ -8972,7 +8972,7 @@
                 <a:solidFill>
                   <a:srgbClr val="1B365D"/>
                 </a:solidFill>
-                <a:latin typeface="Georgia"/>
+                <a:latin typeface="TsangerJinKai02"/>
               </a:defRPr>
             </a:pPr>
             <a:r>
@@ -9008,7 +9008,7 @@
                 <a:solidFill>
                   <a:srgbClr val="141413"/>
                 </a:solidFill>
-                <a:latin typeface="Georgia"/>
+                <a:latin typeface="TsangerJinKai02"/>
               </a:defRPr>
             </a:pPr>
             <a:r>
@@ -9021,7 +9021,7 @@
                 <a:solidFill>
                   <a:srgbClr val="141413"/>
                 </a:solidFill>
-                <a:latin typeface="Georgia"/>
+                <a:latin typeface="TsangerJinKai02"/>
               </a:defRPr>
             </a:pPr>
             <a:r>
@@ -9034,7 +9034,7 @@
                 <a:solidFill>
                   <a:srgbClr val="141413"/>
                 </a:solidFill>
-                <a:latin typeface="Georgia"/>
+                <a:latin typeface="TsangerJinKai02"/>
               </a:defRPr>
             </a:pPr>
             <a:r>
@@ -9047,7 +9047,7 @@
                 <a:solidFill>
                   <a:srgbClr val="141413"/>
                 </a:solidFill>
-                <a:latin typeface="Georgia"/>
+                <a:latin typeface="TsangerJinKai02"/>
               </a:defRPr>
             </a:pPr>
             <a:r>
@@ -9060,7 +9060,7 @@
                 <a:solidFill>
                   <a:srgbClr val="141413"/>
                 </a:solidFill>
-                <a:latin typeface="Georgia"/>
+                <a:latin typeface="TsangerJinKai02"/>
               </a:defRPr>
             </a:pPr>
             <a:r>
@@ -9237,7 +9237,7 @@
                 <a:solidFill>
                   <a:srgbClr val="1B365D"/>
                 </a:solidFill>
-                <a:latin typeface="Georgia"/>
+                <a:latin typeface="TsangerJinKai02"/>
               </a:defRPr>
             </a:pPr>
             <a:r>
@@ -9263,7 +9263,7 @@
         <p:spPr>
           <a:xfrm>
             <a:off x="685800" y="1298448"/>
-            <a:ext cx="8778240" cy="3912473"/>
+            <a:ext cx="8778240" cy="3913012"/>
           </a:xfrm>
           <a:prstGeom prst="rect">
             <a:avLst/>
@@ -9297,7 +9297,7 @@
                 <a:solidFill>
                   <a:srgbClr val="141413"/>
                 </a:solidFill>
-                <a:latin typeface="Georgia"/>
+                <a:latin typeface="TsangerJinKai02"/>
               </a:defRPr>
             </a:pPr>
             <a:r>
@@ -9310,7 +9310,7 @@
                 <a:solidFill>
                   <a:srgbClr val="141413"/>
                 </a:solidFill>
-                <a:latin typeface="Georgia"/>
+                <a:latin typeface="TsangerJinKai02"/>
               </a:defRPr>
             </a:pPr>
             <a:r>
@@ -9323,7 +9323,7 @@
                 <a:solidFill>
                   <a:srgbClr val="141413"/>
                 </a:solidFill>
-                <a:latin typeface="Georgia"/>
+                <a:latin typeface="TsangerJinKai02"/>
               </a:defRPr>
             </a:pPr>
             <a:r>
@@ -9336,7 +9336,7 @@
                 <a:solidFill>
                   <a:srgbClr val="141413"/>
                 </a:solidFill>
-                <a:latin typeface="Georgia"/>
+                <a:latin typeface="TsangerJinKai02"/>
               </a:defRPr>
             </a:pPr>
             <a:r>
@@ -9349,7 +9349,7 @@
                 <a:solidFill>
                   <a:srgbClr val="141413"/>
                 </a:solidFill>
-                <a:latin typeface="Georgia"/>
+                <a:latin typeface="TsangerJinKai02"/>
               </a:defRPr>
             </a:pPr>
             <a:r>
@@ -9526,7 +9526,7 @@
                 <a:solidFill>
                   <a:srgbClr val="1B365D"/>
                 </a:solidFill>
-                <a:latin typeface="Georgia"/>
+                <a:latin typeface="TsangerJinKai02"/>
               </a:defRPr>
             </a:pPr>
             <a:r>
@@ -9562,7 +9562,7 @@
                 <a:solidFill>
                   <a:srgbClr val="141413"/>
                 </a:solidFill>
-                <a:latin typeface="Georgia"/>
+                <a:latin typeface="TsangerJinKai02"/>
               </a:defRPr>
             </a:pPr>
             <a:r>
@@ -9575,7 +9575,7 @@
                 <a:solidFill>
                   <a:srgbClr val="141413"/>
                 </a:solidFill>
-                <a:latin typeface="Georgia"/>
+                <a:latin typeface="TsangerJinKai02"/>
               </a:defRPr>
             </a:pPr>
             <a:r>
@@ -9588,7 +9588,7 @@
                 <a:solidFill>
                   <a:srgbClr val="141413"/>
                 </a:solidFill>
-                <a:latin typeface="Georgia"/>
+                <a:latin typeface="TsangerJinKai02"/>
               </a:defRPr>
             </a:pPr>
             <a:r>
@@ -9601,7 +9601,7 @@
                 <a:solidFill>
                   <a:srgbClr val="141413"/>
                 </a:solidFill>
-                <a:latin typeface="Georgia"/>
+                <a:latin typeface="TsangerJinKai02"/>
               </a:defRPr>
             </a:pPr>
             <a:r>
@@ -9614,7 +9614,7 @@
                 <a:solidFill>
                   <a:srgbClr val="141413"/>
                 </a:solidFill>
-                <a:latin typeface="Georgia"/>
+                <a:latin typeface="TsangerJinKai02"/>
               </a:defRPr>
             </a:pPr>
             <a:r>
@@ -9791,7 +9791,7 @@
                 <a:solidFill>
                   <a:srgbClr val="1B365D"/>
                 </a:solidFill>
-                <a:latin typeface="Georgia"/>
+                <a:latin typeface="TsangerJinKai02"/>
               </a:defRPr>
             </a:pPr>
             <a:r>
@@ -9817,7 +9817,7 @@
         <p:spPr>
           <a:xfrm>
             <a:off x="685800" y="1298448"/>
-            <a:ext cx="8778240" cy="890188"/>
+            <a:ext cx="8778240" cy="907452"/>
           </a:xfrm>
           <a:prstGeom prst="rect">
             <a:avLst/>
@@ -9851,7 +9851,7 @@
                 <a:solidFill>
                   <a:srgbClr val="141413"/>
                 </a:solidFill>
-                <a:latin typeface="Georgia"/>
+                <a:latin typeface="TsangerJinKai02"/>
               </a:defRPr>
             </a:pPr>
             <a:r>
@@ -9864,7 +9864,7 @@
                 <a:solidFill>
                   <a:srgbClr val="141413"/>
                 </a:solidFill>
-                <a:latin typeface="Georgia"/>
+                <a:latin typeface="TsangerJinKai02"/>
               </a:defRPr>
             </a:pPr>
             <a:r>
@@ -9877,7 +9877,7 @@
                 <a:solidFill>
                   <a:srgbClr val="141413"/>
                 </a:solidFill>
-                <a:latin typeface="Georgia"/>
+                <a:latin typeface="TsangerJinKai02"/>
               </a:defRPr>
             </a:pPr>
             <a:r>
@@ -9890,7 +9890,7 @@
                 <a:solidFill>
                   <a:srgbClr val="141413"/>
                 </a:solidFill>
-                <a:latin typeface="Georgia"/>
+                <a:latin typeface="TsangerJinKai02"/>
               </a:defRPr>
             </a:pPr>
             <a:r>
@@ -10067,7 +10067,7 @@
                 <a:solidFill>
                   <a:srgbClr val="1B365D"/>
                 </a:solidFill>
-                <a:latin typeface="Georgia"/>
+                <a:latin typeface="TsangerJinKai02"/>
               </a:defRPr>
             </a:pPr>
             <a:r>
@@ -10093,7 +10093,7 @@
         <p:spPr>
           <a:xfrm>
             <a:off x="685800" y="1298448"/>
-            <a:ext cx="8778240" cy="838685"/>
+            <a:ext cx="8778240" cy="838415"/>
           </a:xfrm>
           <a:prstGeom prst="rect">
             <a:avLst/>
@@ -10127,7 +10127,7 @@
                 <a:solidFill>
                   <a:srgbClr val="141413"/>
                 </a:solidFill>
-                <a:latin typeface="Georgia"/>
+                <a:latin typeface="TsangerJinKai02"/>
               </a:defRPr>
             </a:pPr>
             <a:r>
@@ -10140,7 +10140,7 @@
                 <a:solidFill>
                   <a:srgbClr val="141413"/>
                 </a:solidFill>
-                <a:latin typeface="Georgia"/>
+                <a:latin typeface="TsangerJinKai02"/>
               </a:defRPr>
             </a:pPr>
             <a:r>
@@ -10153,7 +10153,7 @@
                 <a:solidFill>
                   <a:srgbClr val="141413"/>
                 </a:solidFill>
-                <a:latin typeface="Georgia"/>
+                <a:latin typeface="TsangerJinKai02"/>
               </a:defRPr>
             </a:pPr>
             <a:r>
@@ -10166,7 +10166,7 @@
                 <a:solidFill>
                   <a:srgbClr val="141413"/>
                 </a:solidFill>
-                <a:latin typeface="Georgia"/>
+                <a:latin typeface="TsangerJinKai02"/>
               </a:defRPr>
             </a:pPr>
             <a:r>
@@ -10179,7 +10179,7 @@
                 <a:solidFill>
                   <a:srgbClr val="141413"/>
                 </a:solidFill>
-                <a:latin typeface="Georgia"/>
+                <a:latin typeface="TsangerJinKai02"/>
               </a:defRPr>
             </a:pPr>
             <a:r>
@@ -10356,7 +10356,7 @@
                 <a:solidFill>
                   <a:srgbClr val="1B365D"/>
                 </a:solidFill>
-                <a:latin typeface="Georgia"/>
+                <a:latin typeface="TsangerJinKai02"/>
               </a:defRPr>
             </a:pPr>
             <a:r>
@@ -10382,7 +10382,7 @@
         <p:spPr>
           <a:xfrm>
             <a:off x="685800" y="1298448"/>
-            <a:ext cx="8778240" cy="2141034"/>
+            <a:ext cx="8778240" cy="2108604"/>
           </a:xfrm>
           <a:prstGeom prst="rect">
             <a:avLst/>
@@ -10416,7 +10416,7 @@
                 <a:solidFill>
                   <a:srgbClr val="141413"/>
                 </a:solidFill>
-                <a:latin typeface="Georgia"/>
+                <a:latin typeface="TsangerJinKai02"/>
               </a:defRPr>
             </a:pPr>
             <a:r>
@@ -10429,7 +10429,7 @@
                 <a:solidFill>
                   <a:srgbClr val="141413"/>
                 </a:solidFill>
-                <a:latin typeface="Georgia"/>
+                <a:latin typeface="TsangerJinKai02"/>
               </a:defRPr>
             </a:pPr>
             <a:r>
@@ -10442,7 +10442,7 @@
                 <a:solidFill>
                   <a:srgbClr val="141413"/>
                 </a:solidFill>
-                <a:latin typeface="Georgia"/>
+                <a:latin typeface="TsangerJinKai02"/>
               </a:defRPr>
             </a:pPr>
             <a:r>
@@ -10455,7 +10455,7 @@
                 <a:solidFill>
                   <a:srgbClr val="141413"/>
                 </a:solidFill>
-                <a:latin typeface="Georgia"/>
+                <a:latin typeface="TsangerJinKai02"/>
               </a:defRPr>
             </a:pPr>
             <a:r>
@@ -10632,7 +10632,7 @@
                 <a:solidFill>
                   <a:srgbClr val="1B365D"/>
                 </a:solidFill>
-                <a:latin typeface="Georgia"/>
+                <a:latin typeface="TsangerJinKai02"/>
               </a:defRPr>
             </a:pPr>
             <a:r>
@@ -10668,7 +10668,7 @@
                 <a:solidFill>
                   <a:srgbClr val="141413"/>
                 </a:solidFill>
-                <a:latin typeface="Georgia"/>
+                <a:latin typeface="TsangerJinKai02"/>
               </a:defRPr>
             </a:pPr>
             <a:r>
@@ -10681,7 +10681,7 @@
                 <a:solidFill>
                   <a:srgbClr val="141413"/>
                 </a:solidFill>
-                <a:latin typeface="Georgia"/>
+                <a:latin typeface="TsangerJinKai02"/>
               </a:defRPr>
             </a:pPr>
             <a:r>
@@ -10694,7 +10694,7 @@
                 <a:solidFill>
                   <a:srgbClr val="141413"/>
                 </a:solidFill>
-                <a:latin typeface="Georgia"/>
+                <a:latin typeface="TsangerJinKai02"/>
               </a:defRPr>
             </a:pPr>
             <a:r>
@@ -10707,7 +10707,7 @@
                 <a:solidFill>
                   <a:srgbClr val="141413"/>
                 </a:solidFill>
-                <a:latin typeface="Georgia"/>
+                <a:latin typeface="TsangerJinKai02"/>
               </a:defRPr>
             </a:pPr>
             <a:r>
@@ -10720,7 +10720,7 @@
                 <a:solidFill>
                   <a:srgbClr val="141413"/>
                 </a:solidFill>
-                <a:latin typeface="Georgia"/>
+                <a:latin typeface="TsangerJinKai02"/>
               </a:defRPr>
             </a:pPr>
             <a:r>
@@ -10897,7 +10897,7 @@
                 <a:solidFill>
                   <a:srgbClr val="1B365D"/>
                 </a:solidFill>
-                <a:latin typeface="Georgia"/>
+                <a:latin typeface="TsangerJinKai02"/>
               </a:defRPr>
             </a:pPr>
             <a:r>
@@ -10923,7 +10923,7 @@
         <p:spPr>
           <a:xfrm>
             <a:off x="685800" y="1298448"/>
-            <a:ext cx="8778240" cy="1126541"/>
+            <a:ext cx="8778240" cy="1117824"/>
           </a:xfrm>
           <a:prstGeom prst="rect">
             <a:avLst/>
@@ -10957,7 +10957,7 @@
                 <a:solidFill>
                   <a:srgbClr val="141413"/>
                 </a:solidFill>
-                <a:latin typeface="Georgia"/>
+                <a:latin typeface="TsangerJinKai02"/>
               </a:defRPr>
             </a:pPr>
             <a:r>
@@ -10970,7 +10970,7 @@
                 <a:solidFill>
                   <a:srgbClr val="141413"/>
                 </a:solidFill>
-                <a:latin typeface="Georgia"/>
+                <a:latin typeface="TsangerJinKai02"/>
               </a:defRPr>
             </a:pPr>
             <a:r>
@@ -10983,7 +10983,7 @@
                 <a:solidFill>
                   <a:srgbClr val="141413"/>
                 </a:solidFill>
-                <a:latin typeface="Georgia"/>
+                <a:latin typeface="TsangerJinKai02"/>
               </a:defRPr>
             </a:pPr>
             <a:r>
@@ -10996,7 +10996,7 @@
                 <a:solidFill>
                   <a:srgbClr val="141413"/>
                 </a:solidFill>
-                <a:latin typeface="Georgia"/>
+                <a:latin typeface="TsangerJinKai02"/>
               </a:defRPr>
             </a:pPr>
             <a:r>
@@ -11173,7 +11173,7 @@
                 <a:solidFill>
                   <a:srgbClr val="1B365D"/>
                 </a:solidFill>
-                <a:latin typeface="Georgia"/>
+                <a:latin typeface="TsangerJinKai02"/>
               </a:defRPr>
             </a:pPr>
             <a:r>
@@ -11199,7 +11199,7 @@
         <p:spPr>
           <a:xfrm>
             <a:off x="685800" y="1298448"/>
-            <a:ext cx="8778240" cy="858368"/>
+            <a:ext cx="8778240" cy="857247"/>
           </a:xfrm>
           <a:prstGeom prst="rect">
             <a:avLst/>
@@ -11233,7 +11233,7 @@
                 <a:solidFill>
                   <a:srgbClr val="141413"/>
                 </a:solidFill>
-                <a:latin typeface="Georgia"/>
+                <a:latin typeface="TsangerJinKai02"/>
               </a:defRPr>
             </a:pPr>
             <a:r>
@@ -11246,7 +11246,7 @@
                 <a:solidFill>
                   <a:srgbClr val="141413"/>
                 </a:solidFill>
-                <a:latin typeface="Georgia"/>
+                <a:latin typeface="TsangerJinKai02"/>
               </a:defRPr>
             </a:pPr>
             <a:r>
@@ -11259,7 +11259,7 @@
                 <a:solidFill>
                   <a:srgbClr val="141413"/>
                 </a:solidFill>
-                <a:latin typeface="Georgia"/>
+                <a:latin typeface="TsangerJinKai02"/>
               </a:defRPr>
             </a:pPr>
             <a:r>
@@ -11272,7 +11272,7 @@
                 <a:solidFill>
                   <a:srgbClr val="141413"/>
                 </a:solidFill>
-                <a:latin typeface="Georgia"/>
+                <a:latin typeface="TsangerJinKai02"/>
               </a:defRPr>
             </a:pPr>
             <a:r>
@@ -11285,7 +11285,7 @@
                 <a:solidFill>
                   <a:srgbClr val="141413"/>
                 </a:solidFill>
-                <a:latin typeface="Georgia"/>
+                <a:latin typeface="TsangerJinKai02"/>
               </a:defRPr>
             </a:pPr>
             <a:r>
@@ -11462,7 +11462,7 @@
                 <a:solidFill>
                   <a:srgbClr val="1B365D"/>
                 </a:solidFill>
-                <a:latin typeface="Georgia"/>
+                <a:latin typeface="TsangerJinKai02"/>
               </a:defRPr>
             </a:pPr>
             <a:r>
@@ -11498,7 +11498,7 @@
                 <a:solidFill>
                   <a:srgbClr val="141413"/>
                 </a:solidFill>
-                <a:latin typeface="Georgia"/>
+                <a:latin typeface="TsangerJinKai02"/>
               </a:defRPr>
             </a:pPr>
             <a:r>
@@ -11511,7 +11511,7 @@
                 <a:solidFill>
                   <a:srgbClr val="141413"/>
                 </a:solidFill>
-                <a:latin typeface="Georgia"/>
+                <a:latin typeface="TsangerJinKai02"/>
               </a:defRPr>
             </a:pPr>
             <a:r>
@@ -11524,7 +11524,7 @@
                 <a:solidFill>
                   <a:srgbClr val="141413"/>
                 </a:solidFill>
-                <a:latin typeface="Georgia"/>
+                <a:latin typeface="TsangerJinKai02"/>
               </a:defRPr>
             </a:pPr>
             <a:r>
@@ -11537,7 +11537,7 @@
                 <a:solidFill>
                   <a:srgbClr val="141413"/>
                 </a:solidFill>
-                <a:latin typeface="Georgia"/>
+                <a:latin typeface="TsangerJinKai02"/>
               </a:defRPr>
             </a:pPr>
             <a:r>
@@ -11550,7 +11550,7 @@
                 <a:solidFill>
                   <a:srgbClr val="141413"/>
                 </a:solidFill>
-                <a:latin typeface="Georgia"/>
+                <a:latin typeface="TsangerJinKai02"/>
               </a:defRPr>
             </a:pPr>
             <a:r>
@@ -11727,7 +11727,7 @@
                 <a:solidFill>
                   <a:srgbClr val="1B365D"/>
                 </a:solidFill>
-                <a:latin typeface="Georgia"/>
+                <a:latin typeface="TsangerJinKai02"/>
               </a:defRPr>
             </a:pPr>
             <a:r>
@@ -11753,7 +11753,7 @@
         <p:spPr>
           <a:xfrm>
             <a:off x="685800" y="1298448"/>
-            <a:ext cx="8778240" cy="1028700"/>
+            <a:ext cx="8778240" cy="1029098"/>
           </a:xfrm>
           <a:prstGeom prst="rect">
             <a:avLst/>
@@ -11787,7 +11787,7 @@
                 <a:solidFill>
                   <a:srgbClr val="141413"/>
                 </a:solidFill>
-                <a:latin typeface="Georgia"/>
+                <a:latin typeface="TsangerJinKai02"/>
               </a:defRPr>
             </a:pPr>
             <a:r>
@@ -11800,7 +11800,7 @@
                 <a:solidFill>
                   <a:srgbClr val="141413"/>
                 </a:solidFill>
-                <a:latin typeface="Georgia"/>
+                <a:latin typeface="TsangerJinKai02"/>
               </a:defRPr>
             </a:pPr>
             <a:r>
@@ -11813,7 +11813,7 @@
                 <a:solidFill>
                   <a:srgbClr val="141413"/>
                 </a:solidFill>
-                <a:latin typeface="Georgia"/>
+                <a:latin typeface="TsangerJinKai02"/>
               </a:defRPr>
             </a:pPr>
             <a:r>
@@ -11826,7 +11826,7 @@
                 <a:solidFill>
                   <a:srgbClr val="141413"/>
                 </a:solidFill>
-                <a:latin typeface="Georgia"/>
+                <a:latin typeface="TsangerJinKai02"/>
               </a:defRPr>
             </a:pPr>
             <a:r>
@@ -12003,7 +12003,7 @@
                 <a:solidFill>
                   <a:srgbClr val="1B365D"/>
                 </a:solidFill>
-                <a:latin typeface="Georgia"/>
+                <a:latin typeface="TsangerJinKai02"/>
               </a:defRPr>
             </a:pPr>
             <a:r>
@@ -12029,7 +12029,7 @@
         <p:spPr>
           <a:xfrm>
             <a:off x="685800" y="1298448"/>
-            <a:ext cx="8778240" cy="937846"/>
+            <a:ext cx="8778240" cy="935843"/>
           </a:xfrm>
           <a:prstGeom prst="rect">
             <a:avLst/>
@@ -12063,7 +12063,7 @@
                 <a:solidFill>
                   <a:srgbClr val="141413"/>
                 </a:solidFill>
-                <a:latin typeface="Georgia"/>
+                <a:latin typeface="TsangerJinKai02"/>
               </a:defRPr>
             </a:pPr>
             <a:r>
@@ -12076,7 +12076,7 @@
                 <a:solidFill>
                   <a:srgbClr val="141413"/>
                 </a:solidFill>
-                <a:latin typeface="Georgia"/>
+                <a:latin typeface="TsangerJinKai02"/>
               </a:defRPr>
             </a:pPr>
             <a:r>
@@ -12089,7 +12089,7 @@
                 <a:solidFill>
                   <a:srgbClr val="141413"/>
                 </a:solidFill>
-                <a:latin typeface="Georgia"/>
+                <a:latin typeface="TsangerJinKai02"/>
               </a:defRPr>
             </a:pPr>
             <a:r>
@@ -12102,7 +12102,7 @@
                 <a:solidFill>
                   <a:srgbClr val="141413"/>
                 </a:solidFill>
-                <a:latin typeface="Georgia"/>
+                <a:latin typeface="TsangerJinKai02"/>
               </a:defRPr>
             </a:pPr>
             <a:r>
@@ -12279,7 +12279,7 @@
                 <a:solidFill>
                   <a:srgbClr val="1B365D"/>
                 </a:solidFill>
-                <a:latin typeface="Georgia"/>
+                <a:latin typeface="TsangerJinKai02"/>
               </a:defRPr>
             </a:pPr>
             <a:r>
@@ -12305,7 +12305,7 @@
         <p:spPr>
           <a:xfrm>
             <a:off x="685800" y="1298448"/>
-            <a:ext cx="8778240" cy="447217"/>
+            <a:ext cx="8778240" cy="431241"/>
           </a:xfrm>
           <a:prstGeom prst="rect">
             <a:avLst/>
@@ -12339,7 +12339,7 @@
                 <a:solidFill>
                   <a:srgbClr val="141413"/>
                 </a:solidFill>
-                <a:latin typeface="Georgia"/>
+                <a:latin typeface="TsangerJinKai02"/>
               </a:defRPr>
             </a:pPr>
             <a:r>
@@ -12352,7 +12352,7 @@
                 <a:solidFill>
                   <a:srgbClr val="141413"/>
                 </a:solidFill>
-                <a:latin typeface="Georgia"/>
+                <a:latin typeface="TsangerJinKai02"/>
               </a:defRPr>
             </a:pPr>
             <a:r>
@@ -12365,7 +12365,7 @@
                 <a:solidFill>
                   <a:srgbClr val="141413"/>
                 </a:solidFill>
-                <a:latin typeface="Georgia"/>
+                <a:latin typeface="TsangerJinKai02"/>
               </a:defRPr>
             </a:pPr>
             <a:r>
@@ -12378,7 +12378,7 @@
                 <a:solidFill>
                   <a:srgbClr val="141413"/>
                 </a:solidFill>
-                <a:latin typeface="Georgia"/>
+                <a:latin typeface="TsangerJinKai02"/>
               </a:defRPr>
             </a:pPr>
             <a:r>
@@ -12555,7 +12555,7 @@
                 <a:solidFill>
                   <a:srgbClr val="1B365D"/>
                 </a:solidFill>
-                <a:latin typeface="Georgia"/>
+                <a:latin typeface="TsangerJinKai02"/>
               </a:defRPr>
             </a:pPr>
             <a:r>
@@ -12581,7 +12581,7 @@
         <p:spPr>
           <a:xfrm>
             <a:off x="685800" y="1298448"/>
-            <a:ext cx="8778240" cy="661676"/>
+            <a:ext cx="8778240" cy="661508"/>
           </a:xfrm>
           <a:prstGeom prst="rect">
             <a:avLst/>
@@ -12615,7 +12615,7 @@
                 <a:solidFill>
                   <a:srgbClr val="141413"/>
                 </a:solidFill>
-                <a:latin typeface="Georgia"/>
+                <a:latin typeface="TsangerJinKai02"/>
               </a:defRPr>
             </a:pPr>
             <a:r>
@@ -12628,7 +12628,7 @@
                 <a:solidFill>
                   <a:srgbClr val="141413"/>
                 </a:solidFill>
-                <a:latin typeface="Georgia"/>
+                <a:latin typeface="TsangerJinKai02"/>
               </a:defRPr>
             </a:pPr>
             <a:r>
@@ -12641,7 +12641,7 @@
                 <a:solidFill>
                   <a:srgbClr val="141413"/>
                 </a:solidFill>
-                <a:latin typeface="Georgia"/>
+                <a:latin typeface="TsangerJinKai02"/>
               </a:defRPr>
             </a:pPr>
             <a:r>
@@ -12654,7 +12654,7 @@
                 <a:solidFill>
                   <a:srgbClr val="141413"/>
                 </a:solidFill>
-                <a:latin typeface="Georgia"/>
+                <a:latin typeface="TsangerJinKai02"/>
               </a:defRPr>
             </a:pPr>
             <a:r>
@@ -12831,7 +12831,7 @@
                 <a:solidFill>
                   <a:srgbClr val="1B365D"/>
                 </a:solidFill>
-                <a:latin typeface="Georgia"/>
+                <a:latin typeface="TsangerJinKai02"/>
               </a:defRPr>
             </a:pPr>
             <a:r>
@@ -12857,7 +12857,7 @@
         <p:spPr>
           <a:xfrm>
             <a:off x="685800" y="1298448"/>
-            <a:ext cx="8778240" cy="1271697"/>
+            <a:ext cx="8778240" cy="1295579"/>
           </a:xfrm>
           <a:prstGeom prst="rect">
             <a:avLst/>
@@ -12891,7 +12891,7 @@
                 <a:solidFill>
                   <a:srgbClr val="141413"/>
                 </a:solidFill>
-                <a:latin typeface="Georgia"/>
+                <a:latin typeface="TsangerJinKai02"/>
               </a:defRPr>
             </a:pPr>
             <a:r>
@@ -12904,7 +12904,7 @@
                 <a:solidFill>
                   <a:srgbClr val="141413"/>
                 </a:solidFill>
-                <a:latin typeface="Georgia"/>
+                <a:latin typeface="TsangerJinKai02"/>
               </a:defRPr>
             </a:pPr>
             <a:r>
@@ -12917,7 +12917,7 @@
                 <a:solidFill>
                   <a:srgbClr val="141413"/>
                 </a:solidFill>
-                <a:latin typeface="Georgia"/>
+                <a:latin typeface="TsangerJinKai02"/>
               </a:defRPr>
             </a:pPr>
             <a:r>
@@ -12930,7 +12930,7 @@
                 <a:solidFill>
                   <a:srgbClr val="141413"/>
                 </a:solidFill>
-                <a:latin typeface="Georgia"/>
+                <a:latin typeface="TsangerJinKai02"/>
               </a:defRPr>
             </a:pPr>
             <a:r>
@@ -12943,7 +12943,7 @@
                 <a:solidFill>
                   <a:srgbClr val="141413"/>
                 </a:solidFill>
-                <a:latin typeface="Georgia"/>
+                <a:latin typeface="TsangerJinKai02"/>
               </a:defRPr>
             </a:pPr>
             <a:r>
@@ -13120,7 +13120,7 @@
                 <a:solidFill>
                   <a:srgbClr val="1B365D"/>
                 </a:solidFill>
-                <a:latin typeface="Georgia"/>
+                <a:latin typeface="TsangerJinKai02"/>
               </a:defRPr>
             </a:pPr>
             <a:r>
@@ -13146,7 +13146,7 @@
         <p:spPr>
           <a:xfrm>
             <a:off x="685800" y="1298448"/>
-            <a:ext cx="8778240" cy="890188"/>
+            <a:ext cx="8778240" cy="907452"/>
           </a:xfrm>
           <a:prstGeom prst="rect">
             <a:avLst/>
@@ -13180,7 +13180,7 @@
                 <a:solidFill>
                   <a:srgbClr val="141413"/>
                 </a:solidFill>
-                <a:latin typeface="Georgia"/>
+                <a:latin typeface="TsangerJinKai02"/>
               </a:defRPr>
             </a:pPr>
             <a:r>
@@ -13193,7 +13193,7 @@
                 <a:solidFill>
                   <a:srgbClr val="141413"/>
                 </a:solidFill>
-                <a:latin typeface="Georgia"/>
+                <a:latin typeface="TsangerJinKai02"/>
               </a:defRPr>
             </a:pPr>
             <a:r>
@@ -13206,7 +13206,7 @@
                 <a:solidFill>
                   <a:srgbClr val="141413"/>
                 </a:solidFill>
-                <a:latin typeface="Georgia"/>
+                <a:latin typeface="TsangerJinKai02"/>
               </a:defRPr>
             </a:pPr>
             <a:r>
@@ -13219,7 +13219,7 @@
                 <a:solidFill>
                   <a:srgbClr val="141413"/>
                 </a:solidFill>
-                <a:latin typeface="Georgia"/>
+                <a:latin typeface="TsangerJinKai02"/>
               </a:defRPr>
             </a:pPr>
             <a:r>
@@ -13396,7 +13396,7 @@
                 <a:solidFill>
                   <a:srgbClr val="1B365D"/>
                 </a:solidFill>
-                <a:latin typeface="Georgia"/>
+                <a:latin typeface="TsangerJinKai02"/>
               </a:defRPr>
             </a:pPr>
             <a:r>
@@ -13432,7 +13432,7 @@
                 <a:solidFill>
                   <a:srgbClr val="141413"/>
                 </a:solidFill>
-                <a:latin typeface="Georgia"/>
+                <a:latin typeface="TsangerJinKai02"/>
               </a:defRPr>
             </a:pPr>
             <a:r>
@@ -13445,7 +13445,7 @@
                 <a:solidFill>
                   <a:srgbClr val="141413"/>
                 </a:solidFill>
-                <a:latin typeface="Georgia"/>
+                <a:latin typeface="TsangerJinKai02"/>
               </a:defRPr>
             </a:pPr>
             <a:r>
@@ -13458,7 +13458,7 @@
                 <a:solidFill>
                   <a:srgbClr val="141413"/>
                 </a:solidFill>
-                <a:latin typeface="Georgia"/>
+                <a:latin typeface="TsangerJinKai02"/>
               </a:defRPr>
             </a:pPr>
             <a:r>
@@ -13471,7 +13471,7 @@
                 <a:solidFill>
                   <a:srgbClr val="141413"/>
                 </a:solidFill>
-                <a:latin typeface="Georgia"/>
+                <a:latin typeface="TsangerJinKai02"/>
               </a:defRPr>
             </a:pPr>
             <a:r>
@@ -13648,7 +13648,7 @@
                 <a:solidFill>
                   <a:srgbClr val="1B365D"/>
                 </a:solidFill>
-                <a:latin typeface="Georgia"/>
+                <a:latin typeface="TsangerJinKai02"/>
               </a:defRPr>
             </a:pPr>
             <a:r>
@@ -13684,7 +13684,7 @@
                 <a:solidFill>
                   <a:srgbClr val="141413"/>
                 </a:solidFill>
-                <a:latin typeface="Georgia"/>
+                <a:latin typeface="TsangerJinKai02"/>
               </a:defRPr>
             </a:pPr>
             <a:r>
@@ -13697,7 +13697,7 @@
                 <a:solidFill>
                   <a:srgbClr val="141413"/>
                 </a:solidFill>
-                <a:latin typeface="Georgia"/>
+                <a:latin typeface="TsangerJinKai02"/>
               </a:defRPr>
             </a:pPr>
             <a:r>
@@ -13710,7 +13710,7 @@
                 <a:solidFill>
                   <a:srgbClr val="141413"/>
                 </a:solidFill>
-                <a:latin typeface="Georgia"/>
+                <a:latin typeface="TsangerJinKai02"/>
               </a:defRPr>
             </a:pPr>
             <a:r>
@@ -13723,7 +13723,7 @@
                 <a:solidFill>
                   <a:srgbClr val="141413"/>
                 </a:solidFill>
-                <a:latin typeface="Georgia"/>
+                <a:latin typeface="TsangerJinKai02"/>
               </a:defRPr>
             </a:pPr>
             <a:r>
@@ -13736,7 +13736,7 @@
                 <a:solidFill>
                   <a:srgbClr val="141413"/>
                 </a:solidFill>
-                <a:latin typeface="Georgia"/>
+                <a:latin typeface="TsangerJinKai02"/>
               </a:defRPr>
             </a:pPr>
             <a:r>
@@ -13913,7 +13913,7 @@
                 <a:solidFill>
                   <a:srgbClr val="1B365D"/>
                 </a:solidFill>
-                <a:latin typeface="Georgia"/>
+                <a:latin typeface="TsangerJinKai02"/>
               </a:defRPr>
             </a:pPr>
             <a:r>
@@ -13949,7 +13949,7 @@
                 <a:solidFill>
                   <a:srgbClr val="141413"/>
                 </a:solidFill>
-                <a:latin typeface="Georgia"/>
+                <a:latin typeface="TsangerJinKai02"/>
               </a:defRPr>
             </a:pPr>
             <a:r>
@@ -13962,7 +13962,7 @@
                 <a:solidFill>
                   <a:srgbClr val="141413"/>
                 </a:solidFill>
-                <a:latin typeface="Georgia"/>
+                <a:latin typeface="TsangerJinKai02"/>
               </a:defRPr>
             </a:pPr>
             <a:r>
@@ -13975,7 +13975,7 @@
                 <a:solidFill>
                   <a:srgbClr val="141413"/>
                 </a:solidFill>
-                <a:latin typeface="Georgia"/>
+                <a:latin typeface="TsangerJinKai02"/>
               </a:defRPr>
             </a:pPr>
             <a:r>
@@ -13988,7 +13988,7 @@
                 <a:solidFill>
                   <a:srgbClr val="141413"/>
                 </a:solidFill>
-                <a:latin typeface="Georgia"/>
+                <a:latin typeface="TsangerJinKai02"/>
               </a:defRPr>
             </a:pPr>
             <a:r>
@@ -14001,7 +14001,7 @@
                 <a:solidFill>
                   <a:srgbClr val="141413"/>
                 </a:solidFill>
-                <a:latin typeface="Georgia"/>
+                <a:latin typeface="TsangerJinKai02"/>
               </a:defRPr>
             </a:pPr>
             <a:r>
@@ -14178,7 +14178,7 @@
                 <a:solidFill>
                   <a:srgbClr val="1B365D"/>
                 </a:solidFill>
-                <a:latin typeface="Georgia"/>
+                <a:latin typeface="TsangerJinKai02"/>
               </a:defRPr>
             </a:pPr>
             <a:r>
@@ -14214,7 +14214,7 @@
                 <a:solidFill>
                   <a:srgbClr val="141413"/>
                 </a:solidFill>
-                <a:latin typeface="Georgia"/>
+                <a:latin typeface="TsangerJinKai02"/>
               </a:defRPr>
             </a:pPr>
             <a:r>
@@ -14227,7 +14227,7 @@
                 <a:solidFill>
                   <a:srgbClr val="141413"/>
                 </a:solidFill>
-                <a:latin typeface="Georgia"/>
+                <a:latin typeface="TsangerJinKai02"/>
               </a:defRPr>
             </a:pPr>
             <a:r>
@@ -14240,7 +14240,7 @@
                 <a:solidFill>
                   <a:srgbClr val="141413"/>
                 </a:solidFill>
-                <a:latin typeface="Georgia"/>
+                <a:latin typeface="TsangerJinKai02"/>
               </a:defRPr>
             </a:pPr>
             <a:r>
@@ -14253,7 +14253,7 @@
                 <a:solidFill>
                   <a:srgbClr val="141413"/>
                 </a:solidFill>
-                <a:latin typeface="Georgia"/>
+                <a:latin typeface="TsangerJinKai02"/>
               </a:defRPr>
             </a:pPr>
             <a:r>
@@ -14266,7 +14266,7 @@
                 <a:solidFill>
                   <a:srgbClr val="141413"/>
                 </a:solidFill>
-                <a:latin typeface="Georgia"/>
+                <a:latin typeface="TsangerJinKai02"/>
               </a:defRPr>
             </a:pPr>
             <a:r>
@@ -14279,7 +14279,7 @@
                 <a:solidFill>
                   <a:srgbClr val="141413"/>
                 </a:solidFill>
-                <a:latin typeface="Georgia"/>
+                <a:latin typeface="TsangerJinKai02"/>
               </a:defRPr>
             </a:pPr>
             <a:r>
@@ -14456,7 +14456,7 @@
                 <a:solidFill>
                   <a:srgbClr val="1B365D"/>
                 </a:solidFill>
-                <a:latin typeface="Georgia"/>
+                <a:latin typeface="TsangerJinKai02"/>
               </a:defRPr>
             </a:pPr>
             <a:r>
@@ -14492,7 +14492,7 @@
                 <a:solidFill>
                   <a:srgbClr val="141413"/>
                 </a:solidFill>
-                <a:latin typeface="Georgia"/>
+                <a:latin typeface="TsangerJinKai02"/>
               </a:defRPr>
             </a:pPr>
             <a:r>
@@ -14505,7 +14505,7 @@
                 <a:solidFill>
                   <a:srgbClr val="141413"/>
                 </a:solidFill>
-                <a:latin typeface="Georgia"/>
+                <a:latin typeface="TsangerJinKai02"/>
               </a:defRPr>
             </a:pPr>
             <a:r>
@@ -14518,7 +14518,7 @@
                 <a:solidFill>
                   <a:srgbClr val="141413"/>
                 </a:solidFill>
-                <a:latin typeface="Georgia"/>
+                <a:latin typeface="TsangerJinKai02"/>
               </a:defRPr>
             </a:pPr>
             <a:r>
@@ -14531,7 +14531,7 @@
                 <a:solidFill>
                   <a:srgbClr val="141413"/>
                 </a:solidFill>
-                <a:latin typeface="Georgia"/>
+                <a:latin typeface="TsangerJinKai02"/>
               </a:defRPr>
             </a:pPr>
             <a:r>
@@ -14544,7 +14544,7 @@
                 <a:solidFill>
                   <a:srgbClr val="141413"/>
                 </a:solidFill>
-                <a:latin typeface="Georgia"/>
+                <a:latin typeface="TsangerJinKai02"/>
               </a:defRPr>
             </a:pPr>
             <a:r>
@@ -14721,7 +14721,7 @@
                 <a:solidFill>
                   <a:srgbClr val="1B365D"/>
                 </a:solidFill>
-                <a:latin typeface="Georgia"/>
+                <a:latin typeface="TsangerJinKai02"/>
               </a:defRPr>
             </a:pPr>
             <a:r>
@@ -14757,7 +14757,7 @@
                 <a:solidFill>
                   <a:srgbClr val="141413"/>
                 </a:solidFill>
-                <a:latin typeface="Georgia"/>
+                <a:latin typeface="TsangerJinKai02"/>
               </a:defRPr>
             </a:pPr>
             <a:r>
@@ -14770,7 +14770,7 @@
                 <a:solidFill>
                   <a:srgbClr val="141413"/>
                 </a:solidFill>
-                <a:latin typeface="Georgia"/>
+                <a:latin typeface="TsangerJinKai02"/>
               </a:defRPr>
             </a:pPr>
             <a:r>
@@ -14783,7 +14783,7 @@
                 <a:solidFill>
                   <a:srgbClr val="141413"/>
                 </a:solidFill>
-                <a:latin typeface="Georgia"/>
+                <a:latin typeface="TsangerJinKai02"/>
               </a:defRPr>
             </a:pPr>
             <a:r>
@@ -14796,7 +14796,7 @@
                 <a:solidFill>
                   <a:srgbClr val="141413"/>
                 </a:solidFill>
-                <a:latin typeface="Georgia"/>
+                <a:latin typeface="TsangerJinKai02"/>
               </a:defRPr>
             </a:pPr>
             <a:r>
@@ -14973,7 +14973,7 @@
                 <a:solidFill>
                   <a:srgbClr val="1B365D"/>
                 </a:solidFill>
-                <a:latin typeface="Georgia"/>
+                <a:latin typeface="TsangerJinKai02"/>
               </a:defRPr>
             </a:pPr>
             <a:r>
@@ -15009,7 +15009,7 @@
                 <a:solidFill>
                   <a:srgbClr val="141413"/>
                 </a:solidFill>
-                <a:latin typeface="Georgia"/>
+                <a:latin typeface="TsangerJinKai02"/>
               </a:defRPr>
             </a:pPr>
             <a:r>
@@ -15022,7 +15022,7 @@
                 <a:solidFill>
                   <a:srgbClr val="141413"/>
                 </a:solidFill>
-                <a:latin typeface="Georgia"/>
+                <a:latin typeface="TsangerJinKai02"/>
               </a:defRPr>
             </a:pPr>
             <a:r>
@@ -15035,7 +15035,7 @@
                 <a:solidFill>
                   <a:srgbClr val="141413"/>
                 </a:solidFill>
-                <a:latin typeface="Georgia"/>
+                <a:latin typeface="TsangerJinKai02"/>
               </a:defRPr>
             </a:pPr>
             <a:r>
@@ -15048,7 +15048,7 @@
                 <a:solidFill>
                   <a:srgbClr val="141413"/>
                 </a:solidFill>
-                <a:latin typeface="Georgia"/>
+                <a:latin typeface="TsangerJinKai02"/>
               </a:defRPr>
             </a:pPr>
             <a:r>
@@ -15225,7 +15225,7 @@
                 <a:solidFill>
                   <a:srgbClr val="1B365D"/>
                 </a:solidFill>
-                <a:latin typeface="Georgia"/>
+                <a:latin typeface="TsangerJinKai02"/>
               </a:defRPr>
             </a:pPr>
             <a:r>
@@ -15261,7 +15261,7 @@
                 <a:solidFill>
                   <a:srgbClr val="141413"/>
                 </a:solidFill>
-                <a:latin typeface="Georgia"/>
+                <a:latin typeface="TsangerJinKai02"/>
               </a:defRPr>
             </a:pPr>
             <a:r>
@@ -15274,7 +15274,7 @@
                 <a:solidFill>
                   <a:srgbClr val="141413"/>
                 </a:solidFill>
-                <a:latin typeface="Georgia"/>
+                <a:latin typeface="TsangerJinKai02"/>
               </a:defRPr>
             </a:pPr>
             <a:r>
@@ -15287,7 +15287,7 @@
                 <a:solidFill>
                   <a:srgbClr val="141413"/>
                 </a:solidFill>
-                <a:latin typeface="Georgia"/>
+                <a:latin typeface="TsangerJinKai02"/>
               </a:defRPr>
             </a:pPr>
             <a:r>
@@ -15300,7 +15300,7 @@
                 <a:solidFill>
                   <a:srgbClr val="141413"/>
                 </a:solidFill>
-                <a:latin typeface="Georgia"/>
+                <a:latin typeface="TsangerJinKai02"/>
               </a:defRPr>
             </a:pPr>
             <a:r>
@@ -15477,7 +15477,7 @@
                 <a:solidFill>
                   <a:srgbClr val="1B365D"/>
                 </a:solidFill>
-                <a:latin typeface="Georgia"/>
+                <a:latin typeface="TsangerJinKai02"/>
               </a:defRPr>
             </a:pPr>
             <a:r>
@@ -15513,7 +15513,7 @@
                 <a:solidFill>
                   <a:srgbClr val="141413"/>
                 </a:solidFill>
-                <a:latin typeface="Georgia"/>
+                <a:latin typeface="TsangerJinKai02"/>
               </a:defRPr>
             </a:pPr>
             <a:r>
@@ -15526,7 +15526,7 @@
                 <a:solidFill>
                   <a:srgbClr val="141413"/>
                 </a:solidFill>
-                <a:latin typeface="Georgia"/>
+                <a:latin typeface="TsangerJinKai02"/>
               </a:defRPr>
             </a:pPr>
             <a:r>
@@ -15539,7 +15539,7 @@
                 <a:solidFill>
                   <a:srgbClr val="141413"/>
                 </a:solidFill>
-                <a:latin typeface="Georgia"/>
+                <a:latin typeface="TsangerJinKai02"/>
               </a:defRPr>
             </a:pPr>
             <a:r>
@@ -15552,7 +15552,7 @@
                 <a:solidFill>
                   <a:srgbClr val="141413"/>
                 </a:solidFill>
-                <a:latin typeface="Georgia"/>
+                <a:latin typeface="TsangerJinKai02"/>
               </a:defRPr>
             </a:pPr>
             <a:r>
@@ -15729,7 +15729,7 @@
                 <a:solidFill>
                   <a:srgbClr val="1B365D"/>
                 </a:solidFill>
-                <a:latin typeface="Georgia"/>
+                <a:latin typeface="TsangerJinKai02"/>
               </a:defRPr>
             </a:pPr>
             <a:r>
@@ -15765,7 +15765,7 @@
                 <a:solidFill>
                   <a:srgbClr val="141413"/>
                 </a:solidFill>
-                <a:latin typeface="Georgia"/>
+                <a:latin typeface="TsangerJinKai02"/>
               </a:defRPr>
             </a:pPr>
             <a:r>
@@ -15778,7 +15778,7 @@
                 <a:solidFill>
                   <a:srgbClr val="141413"/>
                 </a:solidFill>
-                <a:latin typeface="Georgia"/>
+                <a:latin typeface="TsangerJinKai02"/>
               </a:defRPr>
             </a:pPr>
             <a:r>
@@ -15791,7 +15791,7 @@
                 <a:solidFill>
                   <a:srgbClr val="141413"/>
                 </a:solidFill>
-                <a:latin typeface="Georgia"/>
+                <a:latin typeface="TsangerJinKai02"/>
               </a:defRPr>
             </a:pPr>
             <a:r>
@@ -15804,7 +15804,7 @@
                 <a:solidFill>
                   <a:srgbClr val="141413"/>
                 </a:solidFill>
-                <a:latin typeface="Georgia"/>
+                <a:latin typeface="TsangerJinKai02"/>
               </a:defRPr>
             </a:pPr>
             <a:r>
@@ -15981,7 +15981,7 @@
                 <a:solidFill>
                   <a:srgbClr val="1B365D"/>
                 </a:solidFill>
-                <a:latin typeface="Georgia"/>
+                <a:latin typeface="TsangerJinKai02"/>
               </a:defRPr>
             </a:pPr>
             <a:r>
@@ -16017,7 +16017,7 @@
                 <a:solidFill>
                   <a:srgbClr val="141413"/>
                 </a:solidFill>
-                <a:latin typeface="Georgia"/>
+                <a:latin typeface="TsangerJinKai02"/>
               </a:defRPr>
             </a:pPr>
             <a:r>
@@ -16030,7 +16030,7 @@
                 <a:solidFill>
                   <a:srgbClr val="141413"/>
                 </a:solidFill>
-                <a:latin typeface="Georgia"/>
+                <a:latin typeface="TsangerJinKai02"/>
               </a:defRPr>
             </a:pPr>
             <a:r>
@@ -16043,7 +16043,7 @@
                 <a:solidFill>
                   <a:srgbClr val="141413"/>
                 </a:solidFill>
-                <a:latin typeface="Georgia"/>
+                <a:latin typeface="TsangerJinKai02"/>
               </a:defRPr>
             </a:pPr>
             <a:r>
@@ -16056,7 +16056,7 @@
                 <a:solidFill>
                   <a:srgbClr val="141413"/>
                 </a:solidFill>
-                <a:latin typeface="Georgia"/>
+                <a:latin typeface="TsangerJinKai02"/>
               </a:defRPr>
             </a:pPr>
             <a:r>
@@ -16233,7 +16233,7 @@
                 <a:solidFill>
                   <a:srgbClr val="1B365D"/>
                 </a:solidFill>
-                <a:latin typeface="Georgia"/>
+                <a:latin typeface="TsangerJinKai02"/>
               </a:defRPr>
             </a:pPr>
             <a:r>
@@ -16269,7 +16269,7 @@
                 <a:solidFill>
                   <a:srgbClr val="141413"/>
                 </a:solidFill>
-                <a:latin typeface="Georgia"/>
+                <a:latin typeface="TsangerJinKai02"/>
               </a:defRPr>
             </a:pPr>
             <a:r>
@@ -16282,7 +16282,7 @@
                 <a:solidFill>
                   <a:srgbClr val="141413"/>
                 </a:solidFill>
-                <a:latin typeface="Georgia"/>
+                <a:latin typeface="TsangerJinKai02"/>
               </a:defRPr>
             </a:pPr>
             <a:r>
@@ -16295,7 +16295,7 @@
                 <a:solidFill>
                   <a:srgbClr val="141413"/>
                 </a:solidFill>
-                <a:latin typeface="Georgia"/>
+                <a:latin typeface="TsangerJinKai02"/>
               </a:defRPr>
             </a:pPr>
             <a:r>
@@ -16308,7 +16308,7 @@
                 <a:solidFill>
                   <a:srgbClr val="141413"/>
                 </a:solidFill>
-                <a:latin typeface="Georgia"/>
+                <a:latin typeface="TsangerJinKai02"/>
               </a:defRPr>
             </a:pPr>
             <a:r>
@@ -16485,7 +16485,7 @@
                 <a:solidFill>
                   <a:srgbClr val="1B365D"/>
                 </a:solidFill>
-                <a:latin typeface="Georgia"/>
+                <a:latin typeface="TsangerJinKai02"/>
               </a:defRPr>
             </a:pPr>
             <a:r>
@@ -16521,7 +16521,7 @@
                 <a:solidFill>
                   <a:srgbClr val="141413"/>
                 </a:solidFill>
-                <a:latin typeface="Georgia"/>
+                <a:latin typeface="TsangerJinKai02"/>
               </a:defRPr>
             </a:pPr>
             <a:r>
@@ -16534,7 +16534,7 @@
                 <a:solidFill>
                   <a:srgbClr val="141413"/>
                 </a:solidFill>
-                <a:latin typeface="Georgia"/>
+                <a:latin typeface="TsangerJinKai02"/>
               </a:defRPr>
             </a:pPr>
             <a:r>
@@ -16547,7 +16547,7 @@
                 <a:solidFill>
                   <a:srgbClr val="141413"/>
                 </a:solidFill>
-                <a:latin typeface="Georgia"/>
+                <a:latin typeface="TsangerJinKai02"/>
               </a:defRPr>
             </a:pPr>
             <a:r>
@@ -16560,7 +16560,7 @@
                 <a:solidFill>
                   <a:srgbClr val="141413"/>
                 </a:solidFill>
-                <a:latin typeface="Georgia"/>
+                <a:latin typeface="TsangerJinKai02"/>
               </a:defRPr>
             </a:pPr>
             <a:r>
@@ -16737,7 +16737,7 @@
                 <a:solidFill>
                   <a:srgbClr val="1B365D"/>
                 </a:solidFill>
-                <a:latin typeface="Georgia"/>
+                <a:latin typeface="TsangerJinKai02"/>
               </a:defRPr>
             </a:pPr>
             <a:r>
@@ -16773,7 +16773,7 @@
                 <a:solidFill>
                   <a:srgbClr val="141413"/>
                 </a:solidFill>
-                <a:latin typeface="Georgia"/>
+                <a:latin typeface="TsangerJinKai02"/>
               </a:defRPr>
             </a:pPr>
             <a:r>
@@ -16786,7 +16786,7 @@
                 <a:solidFill>
                   <a:srgbClr val="141413"/>
                 </a:solidFill>
-                <a:latin typeface="Georgia"/>
+                <a:latin typeface="TsangerJinKai02"/>
               </a:defRPr>
             </a:pPr>
             <a:r>
@@ -16799,7 +16799,7 @@
                 <a:solidFill>
                   <a:srgbClr val="141413"/>
                 </a:solidFill>
-                <a:latin typeface="Georgia"/>
+                <a:latin typeface="TsangerJinKai02"/>
               </a:defRPr>
             </a:pPr>
             <a:r>
@@ -16812,7 +16812,7 @@
                 <a:solidFill>
                   <a:srgbClr val="141413"/>
                 </a:solidFill>
-                <a:latin typeface="Georgia"/>
+                <a:latin typeface="TsangerJinKai02"/>
               </a:defRPr>
             </a:pPr>
             <a:r>
@@ -16825,7 +16825,7 @@
                 <a:solidFill>
                   <a:srgbClr val="141413"/>
                 </a:solidFill>
-                <a:latin typeface="Georgia"/>
+                <a:latin typeface="TsangerJinKai02"/>
               </a:defRPr>
             </a:pPr>
             <a:r>
@@ -17002,7 +17002,7 @@
                 <a:solidFill>
                   <a:srgbClr val="1B365D"/>
                 </a:solidFill>
-                <a:latin typeface="Georgia"/>
+                <a:latin typeface="TsangerJinKai02"/>
               </a:defRPr>
             </a:pPr>
             <a:r>
@@ -17038,7 +17038,7 @@
                 <a:solidFill>
                   <a:srgbClr val="141413"/>
                 </a:solidFill>
-                <a:latin typeface="Georgia"/>
+                <a:latin typeface="TsangerJinKai02"/>
               </a:defRPr>
             </a:pPr>
             <a:r>
@@ -17051,7 +17051,7 @@
                 <a:solidFill>
                   <a:srgbClr val="141413"/>
                 </a:solidFill>
-                <a:latin typeface="Georgia"/>
+                <a:latin typeface="TsangerJinKai02"/>
               </a:defRPr>
             </a:pPr>
             <a:r>
@@ -17064,7 +17064,7 @@
                 <a:solidFill>
                   <a:srgbClr val="141413"/>
                 </a:solidFill>
-                <a:latin typeface="Georgia"/>
+                <a:latin typeface="TsangerJinKai02"/>
               </a:defRPr>
             </a:pPr>
             <a:r>
@@ -17077,7 +17077,7 @@
                 <a:solidFill>
                   <a:srgbClr val="141413"/>
                 </a:solidFill>
-                <a:latin typeface="Georgia"/>
+                <a:latin typeface="TsangerJinKai02"/>
               </a:defRPr>
             </a:pPr>
             <a:r>
@@ -17090,7 +17090,7 @@
                 <a:solidFill>
                   <a:srgbClr val="141413"/>
                 </a:solidFill>
-                <a:latin typeface="Georgia"/>
+                <a:latin typeface="TsangerJinKai02"/>
               </a:defRPr>
             </a:pPr>
             <a:r>
@@ -17267,7 +17267,7 @@
                 <a:solidFill>
                   <a:srgbClr val="1B365D"/>
                 </a:solidFill>
-                <a:latin typeface="Georgia"/>
+                <a:latin typeface="TsangerJinKai02"/>
               </a:defRPr>
             </a:pPr>
             <a:r>
@@ -17303,7 +17303,7 @@
                 <a:solidFill>
                   <a:srgbClr val="141413"/>
                 </a:solidFill>
-                <a:latin typeface="Georgia"/>
+                <a:latin typeface="TsangerJinKai02"/>
               </a:defRPr>
             </a:pPr>
             <a:r>
@@ -17316,7 +17316,7 @@
                 <a:solidFill>
                   <a:srgbClr val="141413"/>
                 </a:solidFill>
-                <a:latin typeface="Georgia"/>
+                <a:latin typeface="TsangerJinKai02"/>
               </a:defRPr>
             </a:pPr>
             <a:r>
@@ -17329,7 +17329,7 @@
                 <a:solidFill>
                   <a:srgbClr val="141413"/>
                 </a:solidFill>
-                <a:latin typeface="Georgia"/>
+                <a:latin typeface="TsangerJinKai02"/>
               </a:defRPr>
             </a:pPr>
             <a:r>
@@ -17342,7 +17342,7 @@
                 <a:solidFill>
                   <a:srgbClr val="141413"/>
                 </a:solidFill>
-                <a:latin typeface="Georgia"/>
+                <a:latin typeface="TsangerJinKai02"/>
               </a:defRPr>
             </a:pPr>
             <a:r>
@@ -17355,7 +17355,7 @@
                 <a:solidFill>
                   <a:srgbClr val="141413"/>
                 </a:solidFill>
-                <a:latin typeface="Georgia"/>
+                <a:latin typeface="TsangerJinKai02"/>
               </a:defRPr>
             </a:pPr>
             <a:r>
@@ -17532,7 +17532,7 @@
                 <a:solidFill>
                   <a:srgbClr val="1B365D"/>
                 </a:solidFill>
-                <a:latin typeface="Georgia"/>
+                <a:latin typeface="TsangerJinKai02"/>
               </a:defRPr>
             </a:pPr>
             <a:r>
@@ -17568,7 +17568,7 @@
                 <a:solidFill>
                   <a:srgbClr val="141413"/>
                 </a:solidFill>
-                <a:latin typeface="Georgia"/>
+                <a:latin typeface="TsangerJinKai02"/>
               </a:defRPr>
             </a:pPr>
             <a:r>
@@ -17581,7 +17581,7 @@
                 <a:solidFill>
                   <a:srgbClr val="141413"/>
                 </a:solidFill>
-                <a:latin typeface="Georgia"/>
+                <a:latin typeface="TsangerJinKai02"/>
               </a:defRPr>
             </a:pPr>
             <a:r>
@@ -17594,7 +17594,7 @@
                 <a:solidFill>
                   <a:srgbClr val="141413"/>
                 </a:solidFill>
-                <a:latin typeface="Georgia"/>
+                <a:latin typeface="TsangerJinKai02"/>
               </a:defRPr>
             </a:pPr>
             <a:r>
@@ -17607,7 +17607,7 @@
                 <a:solidFill>
                   <a:srgbClr val="141413"/>
                 </a:solidFill>
-                <a:latin typeface="Georgia"/>
+                <a:latin typeface="TsangerJinKai02"/>
               </a:defRPr>
             </a:pPr>
             <a:r>
@@ -17620,7 +17620,7 @@
                 <a:solidFill>
                   <a:srgbClr val="141413"/>
                 </a:solidFill>
-                <a:latin typeface="Georgia"/>
+                <a:latin typeface="TsangerJinKai02"/>
               </a:defRPr>
             </a:pPr>
             <a:r>
@@ -17797,7 +17797,7 @@
                 <a:solidFill>
                   <a:srgbClr val="1B365D"/>
                 </a:solidFill>
-                <a:latin typeface="Georgia"/>
+                <a:latin typeface="TsangerJinKai02"/>
               </a:defRPr>
             </a:pPr>
             <a:r>
@@ -17833,7 +17833,7 @@
                 <a:solidFill>
                   <a:srgbClr val="141413"/>
                 </a:solidFill>
-                <a:latin typeface="Georgia"/>
+                <a:latin typeface="TsangerJinKai02"/>
               </a:defRPr>
             </a:pPr>
             <a:r>
@@ -17846,7 +17846,7 @@
                 <a:solidFill>
                   <a:srgbClr val="141413"/>
                 </a:solidFill>
-                <a:latin typeface="Georgia"/>
+                <a:latin typeface="TsangerJinKai02"/>
               </a:defRPr>
             </a:pPr>
             <a:r>
@@ -17859,7 +17859,7 @@
                 <a:solidFill>
                   <a:srgbClr val="141413"/>
                 </a:solidFill>
-                <a:latin typeface="Georgia"/>
+                <a:latin typeface="TsangerJinKai02"/>
               </a:defRPr>
             </a:pPr>
             <a:r>
@@ -17872,7 +17872,7 @@
                 <a:solidFill>
                   <a:srgbClr val="141413"/>
                 </a:solidFill>
-                <a:latin typeface="Georgia"/>
+                <a:latin typeface="TsangerJinKai02"/>
               </a:defRPr>
             </a:pPr>
             <a:r>
@@ -17885,7 +17885,7 @@
                 <a:solidFill>
                   <a:srgbClr val="141413"/>
                 </a:solidFill>
-                <a:latin typeface="Georgia"/>
+                <a:latin typeface="TsangerJinKai02"/>
               </a:defRPr>
             </a:pPr>
             <a:r>
@@ -18062,7 +18062,7 @@
                 <a:solidFill>
                   <a:srgbClr val="1B365D"/>
                 </a:solidFill>
-                <a:latin typeface="Georgia"/>
+                <a:latin typeface="TsangerJinKai02"/>
               </a:defRPr>
             </a:pPr>
             <a:r>
@@ -18088,7 +18088,7 @@
         <p:spPr>
           <a:xfrm>
             <a:off x="685800" y="1298448"/>
-            <a:ext cx="8778240" cy="451452"/>
+            <a:ext cx="8778240" cy="464652"/>
           </a:xfrm>
           <a:prstGeom prst="rect">
             <a:avLst/>
@@ -18122,7 +18122,7 @@
                 <a:solidFill>
                   <a:srgbClr val="141413"/>
                 </a:solidFill>
-                <a:latin typeface="Georgia"/>
+                <a:latin typeface="TsangerJinKai02"/>
               </a:defRPr>
             </a:pPr>
             <a:r>
@@ -18135,7 +18135,7 @@
                 <a:solidFill>
                   <a:srgbClr val="141413"/>
                 </a:solidFill>
-                <a:latin typeface="Georgia"/>
+                <a:latin typeface="TsangerJinKai02"/>
               </a:defRPr>
             </a:pPr>
             <a:r>
@@ -18148,7 +18148,7 @@
                 <a:solidFill>
                   <a:srgbClr val="141413"/>
                 </a:solidFill>
-                <a:latin typeface="Georgia"/>
+                <a:latin typeface="TsangerJinKai02"/>
               </a:defRPr>
             </a:pPr>
             <a:r>
@@ -18161,7 +18161,7 @@
                 <a:solidFill>
                   <a:srgbClr val="141413"/>
                 </a:solidFill>
-                <a:latin typeface="Georgia"/>
+                <a:latin typeface="TsangerJinKai02"/>
               </a:defRPr>
             </a:pPr>
             <a:r>
@@ -18338,7 +18338,7 @@
                 <a:solidFill>
                   <a:srgbClr val="1B365D"/>
                 </a:solidFill>
-                <a:latin typeface="Georgia"/>
+                <a:latin typeface="TsangerJinKai02"/>
               </a:defRPr>
             </a:pPr>
             <a:r>
@@ -18374,7 +18374,7 @@
                 <a:solidFill>
                   <a:srgbClr val="141413"/>
                 </a:solidFill>
-                <a:latin typeface="Georgia"/>
+                <a:latin typeface="TsangerJinKai02"/>
               </a:defRPr>
             </a:pPr>
             <a:r>
@@ -18387,7 +18387,7 @@
                 <a:solidFill>
                   <a:srgbClr val="141413"/>
                 </a:solidFill>
-                <a:latin typeface="Georgia"/>
+                <a:latin typeface="TsangerJinKai02"/>
               </a:defRPr>
             </a:pPr>
             <a:r>
@@ -18400,7 +18400,7 @@
                 <a:solidFill>
                   <a:srgbClr val="141413"/>
                 </a:solidFill>
-                <a:latin typeface="Georgia"/>
+                <a:latin typeface="TsangerJinKai02"/>
               </a:defRPr>
             </a:pPr>
             <a:r>
@@ -18413,7 +18413,7 @@
                 <a:solidFill>
                   <a:srgbClr val="141413"/>
                 </a:solidFill>
-                <a:latin typeface="Georgia"/>
+                <a:latin typeface="TsangerJinKai02"/>
               </a:defRPr>
             </a:pPr>
             <a:r>
@@ -18426,7 +18426,7 @@
                 <a:solidFill>
                   <a:srgbClr val="141413"/>
                 </a:solidFill>
-                <a:latin typeface="Georgia"/>
+                <a:latin typeface="TsangerJinKai02"/>
               </a:defRPr>
             </a:pPr>
             <a:r>
@@ -18603,7 +18603,7 @@
                 <a:solidFill>
                   <a:srgbClr val="1B365D"/>
                 </a:solidFill>
-                <a:latin typeface="Georgia"/>
+                <a:latin typeface="TsangerJinKai02"/>
               </a:defRPr>
             </a:pPr>
             <a:r>
@@ -18629,7 +18629,7 @@
         <p:spPr>
           <a:xfrm>
             <a:off x="685800" y="1298448"/>
-            <a:ext cx="8778240" cy="908094"/>
+            <a:ext cx="8778240" cy="907310"/>
           </a:xfrm>
           <a:prstGeom prst="rect">
             <a:avLst/>
@@ -18663,7 +18663,7 @@
                 <a:solidFill>
                   <a:srgbClr val="141413"/>
                 </a:solidFill>
-                <a:latin typeface="Georgia"/>
+                <a:latin typeface="TsangerJinKai02"/>
               </a:defRPr>
             </a:pPr>
             <a:r>
@@ -18676,7 +18676,7 @@
                 <a:solidFill>
                   <a:srgbClr val="141413"/>
                 </a:solidFill>
-                <a:latin typeface="Georgia"/>
+                <a:latin typeface="TsangerJinKai02"/>
               </a:defRPr>
             </a:pPr>
             <a:r>
@@ -18689,7 +18689,7 @@
                 <a:solidFill>
                   <a:srgbClr val="141413"/>
                 </a:solidFill>
-                <a:latin typeface="Georgia"/>
+                <a:latin typeface="TsangerJinKai02"/>
               </a:defRPr>
             </a:pPr>
             <a:r>
@@ -18702,7 +18702,7 @@
                 <a:solidFill>
                   <a:srgbClr val="141413"/>
                 </a:solidFill>
-                <a:latin typeface="Georgia"/>
+                <a:latin typeface="TsangerJinKai02"/>
               </a:defRPr>
             </a:pPr>
             <a:r>
@@ -18879,7 +18879,7 @@
                 <a:solidFill>
                   <a:srgbClr val="1B365D"/>
                 </a:solidFill>
-                <a:latin typeface="Georgia"/>
+                <a:latin typeface="TsangerJinKai02"/>
               </a:defRPr>
             </a:pPr>
             <a:r>
@@ -18905,7 +18905,7 @@
         <p:spPr>
           <a:xfrm>
             <a:off x="685800" y="1298448"/>
-            <a:ext cx="8778240" cy="937846"/>
+            <a:ext cx="8778240" cy="935843"/>
           </a:xfrm>
           <a:prstGeom prst="rect">
             <a:avLst/>
@@ -18939,7 +18939,7 @@
                 <a:solidFill>
                   <a:srgbClr val="141413"/>
                 </a:solidFill>
-                <a:latin typeface="Georgia"/>
+                <a:latin typeface="TsangerJinKai02"/>
               </a:defRPr>
             </a:pPr>
             <a:r>
@@ -18952,7 +18952,7 @@
                 <a:solidFill>
                   <a:srgbClr val="141413"/>
                 </a:solidFill>
-                <a:latin typeface="Georgia"/>
+                <a:latin typeface="TsangerJinKai02"/>
               </a:defRPr>
             </a:pPr>
             <a:r>
@@ -18965,7 +18965,7 @@
                 <a:solidFill>
                   <a:srgbClr val="141413"/>
                 </a:solidFill>
-                <a:latin typeface="Georgia"/>
+                <a:latin typeface="TsangerJinKai02"/>
               </a:defRPr>
             </a:pPr>
             <a:r>
@@ -18978,7 +18978,7 @@
                 <a:solidFill>
                   <a:srgbClr val="141413"/>
                 </a:solidFill>
-                <a:latin typeface="Georgia"/>
+                <a:latin typeface="TsangerJinKai02"/>
               </a:defRPr>
             </a:pPr>
             <a:r>
@@ -19155,7 +19155,7 @@
                 <a:solidFill>
                   <a:srgbClr val="1B365D"/>
                 </a:solidFill>
-                <a:latin typeface="Georgia"/>
+                <a:latin typeface="TsangerJinKai02"/>
               </a:defRPr>
             </a:pPr>
             <a:r>
@@ -19191,7 +19191,7 @@
                 <a:solidFill>
                   <a:srgbClr val="141413"/>
                 </a:solidFill>
-                <a:latin typeface="Georgia"/>
+                <a:latin typeface="TsangerJinKai02"/>
               </a:defRPr>
             </a:pPr>
             <a:r>
@@ -19204,7 +19204,7 @@
                 <a:solidFill>
                   <a:srgbClr val="141413"/>
                 </a:solidFill>
-                <a:latin typeface="Georgia"/>
+                <a:latin typeface="TsangerJinKai02"/>
               </a:defRPr>
             </a:pPr>
             <a:r>
@@ -19217,7 +19217,7 @@
                 <a:solidFill>
                   <a:srgbClr val="141413"/>
                 </a:solidFill>
-                <a:latin typeface="Georgia"/>
+                <a:latin typeface="TsangerJinKai02"/>
               </a:defRPr>
             </a:pPr>
             <a:r>
@@ -19230,7 +19230,7 @@
                 <a:solidFill>
                   <a:srgbClr val="141413"/>
                 </a:solidFill>
-                <a:latin typeface="Georgia"/>
+                <a:latin typeface="TsangerJinKai02"/>
               </a:defRPr>
             </a:pPr>
             <a:r>
@@ -19243,7 +19243,7 @@
                 <a:solidFill>
                   <a:srgbClr val="141413"/>
                 </a:solidFill>
-                <a:latin typeface="Georgia"/>
+                <a:latin typeface="TsangerJinKai02"/>
               </a:defRPr>
             </a:pPr>
             <a:r>
@@ -19420,7 +19420,7 @@
                 <a:solidFill>
                   <a:srgbClr val="1B365D"/>
                 </a:solidFill>
-                <a:latin typeface="Georgia"/>
+                <a:latin typeface="TsangerJinKai02"/>
               </a:defRPr>
             </a:pPr>
             <a:r>
@@ -19456,7 +19456,7 @@
                 <a:solidFill>
                   <a:srgbClr val="141413"/>
                 </a:solidFill>
-                <a:latin typeface="Georgia"/>
+                <a:latin typeface="TsangerJinKai02"/>
               </a:defRPr>
             </a:pPr>
             <a:r>
@@ -19469,7 +19469,7 @@
                 <a:solidFill>
                   <a:srgbClr val="141413"/>
                 </a:solidFill>
-                <a:latin typeface="Georgia"/>
+                <a:latin typeface="TsangerJinKai02"/>
               </a:defRPr>
             </a:pPr>
             <a:r>
@@ -19482,7 +19482,7 @@
                 <a:solidFill>
                   <a:srgbClr val="141413"/>
                 </a:solidFill>
-                <a:latin typeface="Georgia"/>
+                <a:latin typeface="TsangerJinKai02"/>
               </a:defRPr>
             </a:pPr>
             <a:r>
@@ -19495,7 +19495,7 @@
                 <a:solidFill>
                   <a:srgbClr val="141413"/>
                 </a:solidFill>
-                <a:latin typeface="Georgia"/>
+                <a:latin typeface="TsangerJinKai02"/>
               </a:defRPr>
             </a:pPr>
             <a:r>
@@ -19508,7 +19508,7 @@
                 <a:solidFill>
                   <a:srgbClr val="141413"/>
                 </a:solidFill>
-                <a:latin typeface="Georgia"/>
+                <a:latin typeface="TsangerJinKai02"/>
               </a:defRPr>
             </a:pPr>
             <a:r>
@@ -19521,7 +19521,7 @@
                 <a:solidFill>
                   <a:srgbClr val="141413"/>
                 </a:solidFill>
-                <a:latin typeface="Georgia"/>
+                <a:latin typeface="TsangerJinKai02"/>
               </a:defRPr>
             </a:pPr>
             <a:r>
@@ -19698,7 +19698,7 @@
                 <a:solidFill>
                   <a:srgbClr val="1B365D"/>
                 </a:solidFill>
-                <a:latin typeface="Georgia"/>
+                <a:latin typeface="TsangerJinKai02"/>
               </a:defRPr>
             </a:pPr>
             <a:r>
@@ -19734,7 +19734,7 @@
                 <a:solidFill>
                   <a:srgbClr val="141413"/>
                 </a:solidFill>
-                <a:latin typeface="Georgia"/>
+                <a:latin typeface="TsangerJinKai02"/>
               </a:defRPr>
             </a:pPr>
             <a:r>
@@ -19747,7 +19747,7 @@
                 <a:solidFill>
                   <a:srgbClr val="141413"/>
                 </a:solidFill>
-                <a:latin typeface="Georgia"/>
+                <a:latin typeface="TsangerJinKai02"/>
               </a:defRPr>
             </a:pPr>
             <a:r>
@@ -19760,7 +19760,7 @@
                 <a:solidFill>
                   <a:srgbClr val="141413"/>
                 </a:solidFill>
-                <a:latin typeface="Georgia"/>
+                <a:latin typeface="TsangerJinKai02"/>
               </a:defRPr>
             </a:pPr>
             <a:r>
@@ -19773,7 +19773,7 @@
                 <a:solidFill>
                   <a:srgbClr val="141413"/>
                 </a:solidFill>
-                <a:latin typeface="Georgia"/>
+                <a:latin typeface="TsangerJinKai02"/>
               </a:defRPr>
             </a:pPr>
             <a:r>
@@ -19786,7 +19786,7 @@
                 <a:solidFill>
                   <a:srgbClr val="141413"/>
                 </a:solidFill>
-                <a:latin typeface="Georgia"/>
+                <a:latin typeface="TsangerJinKai02"/>
               </a:defRPr>
             </a:pPr>
             <a:r>
@@ -19799,7 +19799,7 @@
                 <a:solidFill>
                   <a:srgbClr val="141413"/>
                 </a:solidFill>
-                <a:latin typeface="Georgia"/>
+                <a:latin typeface="TsangerJinKai02"/>
               </a:defRPr>
             </a:pPr>
             <a:r>
@@ -19976,7 +19976,7 @@
                 <a:solidFill>
                   <a:srgbClr val="1B365D"/>
                 </a:solidFill>
-                <a:latin typeface="Georgia"/>
+                <a:latin typeface="TsangerJinKai02"/>
               </a:defRPr>
             </a:pPr>
             <a:r>
@@ -20012,7 +20012,7 @@
                 <a:solidFill>
                   <a:srgbClr val="141413"/>
                 </a:solidFill>
-                <a:latin typeface="Georgia"/>
+                <a:latin typeface="TsangerJinKai02"/>
               </a:defRPr>
             </a:pPr>
             <a:r>
@@ -20025,7 +20025,7 @@
                 <a:solidFill>
                   <a:srgbClr val="141413"/>
                 </a:solidFill>
-                <a:latin typeface="Georgia"/>
+                <a:latin typeface="TsangerJinKai02"/>
               </a:defRPr>
             </a:pPr>
             <a:r>
@@ -20038,7 +20038,7 @@
                 <a:solidFill>
                   <a:srgbClr val="141413"/>
                 </a:solidFill>
-                <a:latin typeface="Georgia"/>
+                <a:latin typeface="TsangerJinKai02"/>
               </a:defRPr>
             </a:pPr>
             <a:r>
@@ -20051,7 +20051,7 @@
                 <a:solidFill>
                   <a:srgbClr val="141413"/>
                 </a:solidFill>
-                <a:latin typeface="Georgia"/>
+                <a:latin typeface="TsangerJinKai02"/>
               </a:defRPr>
             </a:pPr>
             <a:r>
@@ -20064,7 +20064,7 @@
                 <a:solidFill>
                   <a:srgbClr val="141413"/>
                 </a:solidFill>
-                <a:latin typeface="Georgia"/>
+                <a:latin typeface="TsangerJinKai02"/>
               </a:defRPr>
             </a:pPr>
             <a:r>
@@ -20077,7 +20077,7 @@
                 <a:solidFill>
                   <a:srgbClr val="141413"/>
                 </a:solidFill>
-                <a:latin typeface="Georgia"/>
+                <a:latin typeface="TsangerJinKai02"/>
               </a:defRPr>
             </a:pPr>
             <a:r>
@@ -20254,7 +20254,7 @@
                 <a:solidFill>
                   <a:srgbClr val="1B365D"/>
                 </a:solidFill>
-                <a:latin typeface="Georgia"/>
+                <a:latin typeface="TsangerJinKai02"/>
               </a:defRPr>
             </a:pPr>
             <a:r>
@@ -20290,7 +20290,7 @@
                 <a:solidFill>
                   <a:srgbClr val="141413"/>
                 </a:solidFill>
-                <a:latin typeface="Georgia"/>
+                <a:latin typeface="TsangerJinKai02"/>
               </a:defRPr>
             </a:pPr>
             <a:r>
@@ -20303,7 +20303,7 @@
                 <a:solidFill>
                   <a:srgbClr val="141413"/>
                 </a:solidFill>
-                <a:latin typeface="Georgia"/>
+                <a:latin typeface="TsangerJinKai02"/>
               </a:defRPr>
             </a:pPr>
             <a:r>
@@ -20316,7 +20316,7 @@
                 <a:solidFill>
                   <a:srgbClr val="141413"/>
                 </a:solidFill>
-                <a:latin typeface="Georgia"/>
+                <a:latin typeface="TsangerJinKai02"/>
               </a:defRPr>
             </a:pPr>
             <a:r>
@@ -20329,7 +20329,7 @@
                 <a:solidFill>
                   <a:srgbClr val="141413"/>
                 </a:solidFill>
-                <a:latin typeface="Georgia"/>
+                <a:latin typeface="TsangerJinKai02"/>
               </a:defRPr>
             </a:pPr>
             <a:r>
@@ -20342,7 +20342,7 @@
                 <a:solidFill>
                   <a:srgbClr val="141413"/>
                 </a:solidFill>
-                <a:latin typeface="Georgia"/>
+                <a:latin typeface="TsangerJinKai02"/>
               </a:defRPr>
             </a:pPr>
             <a:r>
@@ -20355,7 +20355,7 @@
                 <a:solidFill>
                   <a:srgbClr val="141413"/>
                 </a:solidFill>
-                <a:latin typeface="Georgia"/>
+                <a:latin typeface="TsangerJinKai02"/>
               </a:defRPr>
             </a:pPr>
             <a:r>
@@ -20532,7 +20532,7 @@
                 <a:solidFill>
                   <a:srgbClr val="1B365D"/>
                 </a:solidFill>
-                <a:latin typeface="Georgia"/>
+                <a:latin typeface="TsangerJinKai02"/>
               </a:defRPr>
             </a:pPr>
             <a:r>
@@ -20568,7 +20568,7 @@
                 <a:solidFill>
                   <a:srgbClr val="141413"/>
                 </a:solidFill>
-                <a:latin typeface="Georgia"/>
+                <a:latin typeface="TsangerJinKai02"/>
               </a:defRPr>
             </a:pPr>
             <a:r>
@@ -20581,7 +20581,7 @@
                 <a:solidFill>
                   <a:srgbClr val="141413"/>
                 </a:solidFill>
-                <a:latin typeface="Georgia"/>
+                <a:latin typeface="TsangerJinKai02"/>
               </a:defRPr>
             </a:pPr>
             <a:r>
@@ -20594,7 +20594,7 @@
                 <a:solidFill>
                   <a:srgbClr val="141413"/>
                 </a:solidFill>
-                <a:latin typeface="Georgia"/>
+                <a:latin typeface="TsangerJinKai02"/>
               </a:defRPr>
             </a:pPr>
             <a:r>
@@ -20607,7 +20607,7 @@
                 <a:solidFill>
                   <a:srgbClr val="141413"/>
                 </a:solidFill>
-                <a:latin typeface="Georgia"/>
+                <a:latin typeface="TsangerJinKai02"/>
               </a:defRPr>
             </a:pPr>
             <a:r>
@@ -20784,7 +20784,7 @@
                 <a:solidFill>
                   <a:srgbClr val="1B365D"/>
                 </a:solidFill>
-                <a:latin typeface="Georgia"/>
+                <a:latin typeface="TsangerJinKai02"/>
               </a:defRPr>
             </a:pPr>
             <a:r>
@@ -20810,7 +20810,7 @@
         <p:spPr>
           <a:xfrm>
             <a:off x="685800" y="1298448"/>
-            <a:ext cx="8778240" cy="642310"/>
+            <a:ext cx="8778240" cy="640741"/>
           </a:xfrm>
           <a:prstGeom prst="rect">
             <a:avLst/>
@@ -20844,7 +20844,7 @@
                 <a:solidFill>
                   <a:srgbClr val="141413"/>
                 </a:solidFill>
-                <a:latin typeface="Georgia"/>
+                <a:latin typeface="TsangerJinKai02"/>
               </a:defRPr>
             </a:pPr>
             <a:r>
@@ -20857,7 +20857,7 @@
                 <a:solidFill>
                   <a:srgbClr val="141413"/>
                 </a:solidFill>
-                <a:latin typeface="Georgia"/>
+                <a:latin typeface="TsangerJinKai02"/>
               </a:defRPr>
             </a:pPr>
             <a:r>
@@ -20870,7 +20870,7 @@
                 <a:solidFill>
                   <a:srgbClr val="141413"/>
                 </a:solidFill>
-                <a:latin typeface="Georgia"/>
+                <a:latin typeface="TsangerJinKai02"/>
               </a:defRPr>
             </a:pPr>
             <a:r>
@@ -20883,7 +20883,7 @@
                 <a:solidFill>
                   <a:srgbClr val="141413"/>
                 </a:solidFill>
-                <a:latin typeface="Georgia"/>
+                <a:latin typeface="TsangerJinKai02"/>
               </a:defRPr>
             </a:pPr>
             <a:r>
@@ -21060,7 +21060,7 @@
                 <a:solidFill>
                   <a:srgbClr val="1B365D"/>
                 </a:solidFill>
-                <a:latin typeface="Georgia"/>
+                <a:latin typeface="TsangerJinKai02"/>
               </a:defRPr>
             </a:pPr>
             <a:r>
@@ -21086,7 +21086,7 @@
         <p:spPr>
           <a:xfrm>
             <a:off x="685800" y="1298448"/>
-            <a:ext cx="8778240" cy="897265"/>
+            <a:ext cx="8778240" cy="896881"/>
           </a:xfrm>
           <a:prstGeom prst="rect">
             <a:avLst/>
@@ -21120,7 +21120,7 @@
                 <a:solidFill>
                   <a:srgbClr val="141413"/>
                 </a:solidFill>
-                <a:latin typeface="Georgia"/>
+                <a:latin typeface="TsangerJinKai02"/>
               </a:defRPr>
             </a:pPr>
             <a:r>
@@ -21133,7 +21133,7 @@
                 <a:solidFill>
                   <a:srgbClr val="141413"/>
                 </a:solidFill>
-                <a:latin typeface="Georgia"/>
+                <a:latin typeface="TsangerJinKai02"/>
               </a:defRPr>
             </a:pPr>
             <a:r>
@@ -21146,7 +21146,7 @@
                 <a:solidFill>
                   <a:srgbClr val="141413"/>
                 </a:solidFill>
-                <a:latin typeface="Georgia"/>
+                <a:latin typeface="TsangerJinKai02"/>
               </a:defRPr>
             </a:pPr>
             <a:r>
@@ -21159,7 +21159,7 @@
                 <a:solidFill>
                   <a:srgbClr val="141413"/>
                 </a:solidFill>
-                <a:latin typeface="Georgia"/>
+                <a:latin typeface="TsangerJinKai02"/>
               </a:defRPr>
             </a:pPr>
             <a:r>

</xml_diff>